<commit_message>
Add team names, problem title and paper number to slide 1
Slide 1 now shows the team (Mahidhar, Sasikanth, Harshith), the problem
title, and the paper under review with its number (IEEE Access vol. 13,
pp. 16133-16149, DOI) and a link. Notes updated to match.

Co-Authored-By: Claude Sonnet 5.5 <noreply@anthropic.com>
Claude-Session: https://claude.ai/code/session_011j42H134gDyTK6hHhsp5dc
</commit_message>
<xml_diff>
--- a/beyond-100/Beyond_100.pptx
+++ b/beyond-100/Beyond_100.pptx
@@ -3517,14 +3517,14 @@
       </p:sp>
       <p:sp>
         <p:nvSpPr>
-          <p:cNvPr id="6" name="TextBox 5"/>
+          <p:cNvPr id="6" name="team"/>
           <p:cNvSpPr txBox="1"/>
           <p:nvPr/>
         </p:nvSpPr>
         <p:spPr>
           <a:xfrm>
-            <a:off x="6309360" y="384048"/>
-            <a:ext cx="5330952" cy="457200"/>
+            <a:off x="5852160" y="384048"/>
+            <a:ext cx="5788152" cy="457200"/>
           </a:xfrm>
           <a:prstGeom prst="rect">
             <a:avLst/>
@@ -3539,13 +3539,22 @@
           <a:p>
             <a:pPr algn="r"/>
             <a:r>
-              <a:rPr sz="1200" b="0" i="0">
-                <a:solidFill>
-                  <a:srgbClr val="9FB3CC"/>
-                </a:solidFill>
-                <a:latin typeface="Calibri"/>
-              </a:rPr>
-              <a:t>Testing and improving ML-based network attack detection</a:t>
+              <a:rPr sz="1100" b="1" i="0" spc="120">
+                <a:solidFill>
+                  <a:srgbClr val="F2A900"/>
+                </a:solidFill>
+                <a:latin typeface="Calibri"/>
+              </a:rPr>
+              <a:t>TEAM   </a:t>
+            </a:r>
+            <a:r>
+              <a:rPr sz="1600" b="1" i="0">
+                <a:solidFill>
+                  <a:srgbClr val="FFFFFF"/>
+                </a:solidFill>
+                <a:latin typeface="Calibri"/>
+              </a:rPr>
+              <a:t>Mahidhar  ·  Sasikanth  ·  Harshith</a:t>
             </a:r>
           </a:p>
         </p:txBody>
@@ -3580,266 +3589,25 @@
                 </a:solidFill>
                 <a:latin typeface="Calibri"/>
               </a:rPr>
-              <a:t>01  ·  WHY IT MATTERS</a:t>
-            </a:r>
-          </a:p>
-        </p:txBody>
-      </p:sp>
-      <p:sp>
-        <p:nvSpPr>
-          <p:cNvPr id="8" name="icon-bg-shield"/>
+              <a:t>01  ·  THE PROBLEM  ·  WHY IT MATTERS</a:t>
+            </a:r>
+          </a:p>
+        </p:txBody>
+      </p:sp>
+      <p:sp>
+        <p:nvSpPr>
+          <p:cNvPr id="8" name="paper-card"/>
           <p:cNvSpPr/>
           <p:nvPr/>
         </p:nvSpPr>
         <p:spPr>
           <a:xfrm>
-            <a:off x="548640" y="3429000"/>
-            <a:ext cx="512064" cy="512064"/>
-          </a:xfrm>
-          <a:prstGeom prst="ellipse">
-            <a:avLst/>
-          </a:prstGeom>
-          <a:solidFill>
-            <a:srgbClr val="2D7FD3"/>
-          </a:solidFill>
-          <a:ln>
-            <a:noFill/>
-          </a:ln>
-          <a:effectLst/>
-        </p:spPr>
-        <p:style>
-          <a:lnRef idx="1">
-            <a:schemeClr val="accent1"/>
-          </a:lnRef>
-          <a:fillRef idx="3">
-            <a:schemeClr val="accent1"/>
-          </a:fillRef>
-          <a:effectRef idx="2">
-            <a:schemeClr val="accent1"/>
-          </a:effectRef>
-          <a:fontRef idx="minor">
-            <a:schemeClr val="lt1"/>
-          </a:fontRef>
-        </p:style>
-        <p:txBody>
-          <a:bodyPr rtlCol="0" anchor="ctr"/>
-          <a:lstStyle/>
-          <a:p>
-            <a:pPr algn="ctr"/>
-          </a:p>
-        </p:txBody>
-      </p:sp>
-      <p:pic>
-        <p:nvPicPr>
-          <p:cNvPr id="9" name="icon-shield" descr="shield icon"/>
-          <p:cNvPicPr>
-            <a:picLocks noChangeAspect="1"/>
-          </p:cNvPicPr>
-          <p:nvPr/>
-        </p:nvPicPr>
-        <p:blipFill>
-          <a:blip r:embed="rId2"/>
-          <a:stretch>
-            <a:fillRect/>
-          </a:stretch>
-        </p:blipFill>
-        <p:spPr>
-          <a:xfrm>
-            <a:off x="656173" y="3536533"/>
-            <a:ext cx="296997" cy="296997"/>
-          </a:xfrm>
-          <a:prstGeom prst="rect">
-            <a:avLst/>
-          </a:prstGeom>
-        </p:spPr>
-      </p:pic>
-      <p:sp>
-        <p:nvSpPr>
-          <p:cNvPr id="10" name="TextBox 9"/>
-          <p:cNvSpPr txBox="1"/>
-          <p:nvPr/>
-        </p:nvSpPr>
-        <p:spPr>
-          <a:xfrm>
-            <a:off x="1280160" y="3383280"/>
-            <a:ext cx="4297680" cy="603504"/>
-          </a:xfrm>
-          <a:prstGeom prst="rect">
-            <a:avLst/>
-          </a:prstGeom>
-          <a:noFill/>
-        </p:spPr>
-        <p:txBody>
-          <a:bodyPr wrap="square" lIns="0" tIns="0" rIns="0" bIns="0" anchor="ctr">
-            <a:spAutoFit/>
-          </a:bodyPr>
-          <a:lstStyle/>
-          <a:p>
-            <a:pPr algn="l"/>
-            <a:r>
-              <a:rPr sz="1600" b="0" i="0">
-                <a:solidFill>
-                  <a:srgbClr val="FFFFFF"/>
-                </a:solidFill>
-                <a:latin typeface="Calibri"/>
-              </a:rPr>
-              <a:t>A detector watches network traffic and flags attacks.</a:t>
-            </a:r>
-          </a:p>
-        </p:txBody>
-      </p:sp>
-      <p:sp>
-        <p:nvSpPr>
-          <p:cNvPr id="11" name="icon-bg-warning"/>
-          <p:cNvSpPr/>
-          <p:nvPr/>
-        </p:nvSpPr>
-        <p:spPr>
-          <a:xfrm>
-            <a:off x="548640" y="4297680"/>
-            <a:ext cx="512064" cy="512064"/>
-          </a:xfrm>
-          <a:prstGeom prst="ellipse">
-            <a:avLst/>
-          </a:prstGeom>
-          <a:solidFill>
-            <a:srgbClr val="2D7FD3"/>
-          </a:solidFill>
-          <a:ln>
-            <a:noFill/>
-          </a:ln>
-          <a:effectLst/>
-        </p:spPr>
-        <p:style>
-          <a:lnRef idx="1">
-            <a:schemeClr val="accent1"/>
-          </a:lnRef>
-          <a:fillRef idx="3">
-            <a:schemeClr val="accent1"/>
-          </a:fillRef>
-          <a:effectRef idx="2">
-            <a:schemeClr val="accent1"/>
-          </a:effectRef>
-          <a:fontRef idx="minor">
-            <a:schemeClr val="lt1"/>
-          </a:fontRef>
-        </p:style>
-        <p:txBody>
-          <a:bodyPr rtlCol="0" anchor="ctr"/>
-          <a:lstStyle/>
-          <a:p>
-            <a:pPr algn="ctr"/>
-          </a:p>
-        </p:txBody>
-      </p:sp>
-      <p:pic>
-        <p:nvPicPr>
-          <p:cNvPr id="12" name="icon-warning" descr="warning icon"/>
-          <p:cNvPicPr>
-            <a:picLocks noChangeAspect="1"/>
-          </p:cNvPicPr>
-          <p:nvPr/>
-        </p:nvPicPr>
-        <p:blipFill>
-          <a:blip r:embed="rId3"/>
-          <a:stretch>
-            <a:fillRect/>
-          </a:stretch>
-        </p:blipFill>
-        <p:spPr>
-          <a:xfrm>
-            <a:off x="656173" y="4405213"/>
-            <a:ext cx="296997" cy="296997"/>
-          </a:xfrm>
-          <a:prstGeom prst="rect">
-            <a:avLst/>
-          </a:prstGeom>
-        </p:spPr>
-      </p:pic>
-      <p:sp>
-        <p:nvSpPr>
-          <p:cNvPr id="13" name="TextBox 12"/>
-          <p:cNvSpPr txBox="1"/>
-          <p:nvPr/>
-        </p:nvSpPr>
-        <p:spPr>
-          <a:xfrm>
-            <a:off x="1280160" y="4251960"/>
-            <a:ext cx="4297680" cy="603504"/>
-          </a:xfrm>
-          <a:prstGeom prst="rect">
-            <a:avLst/>
-          </a:prstGeom>
-          <a:noFill/>
-        </p:spPr>
-        <p:txBody>
-          <a:bodyPr wrap="square" lIns="0" tIns="0" rIns="0" bIns="0" anchor="ctr">
-            <a:spAutoFit/>
-          </a:bodyPr>
-          <a:lstStyle/>
-          <a:p>
-            <a:pPr algn="l"/>
-            <a:r>
-              <a:rPr sz="1600" b="0" i="0">
-                <a:solidFill>
-                  <a:srgbClr val="FFFFFF"/>
-                </a:solidFill>
-                <a:latin typeface="Calibri"/>
-              </a:rPr>
-              <a:t>A missed attack costs money. A false alarm wastes analysts' time.</a:t>
-            </a:r>
-          </a:p>
-        </p:txBody>
-      </p:sp>
-      <p:sp>
-        <p:nvSpPr>
-          <p:cNvPr id="14" name="TextBox 13"/>
-          <p:cNvSpPr txBox="1"/>
-          <p:nvPr/>
-        </p:nvSpPr>
-        <p:spPr>
-          <a:xfrm>
-            <a:off x="6309360" y="1188720"/>
-            <a:ext cx="5303520" cy="274320"/>
-          </a:xfrm>
-          <a:prstGeom prst="rect">
-            <a:avLst/>
-          </a:prstGeom>
-          <a:noFill/>
-        </p:spPr>
-        <p:txBody>
-          <a:bodyPr wrap="square" lIns="0" tIns="0" rIns="0" bIns="0" anchor="t">
-            <a:spAutoFit/>
-          </a:bodyPr>
-          <a:lstStyle/>
-          <a:p>
-            <a:pPr algn="l"/>
-            <a:r>
-              <a:rPr sz="1200" b="1" i="0" spc="120">
-                <a:solidFill>
-                  <a:srgbClr val="F2A900"/>
-                </a:solidFill>
-                <a:latin typeface="Calibri"/>
-              </a:rPr>
-              <a:t>INDUSTRY LOSS  ·  WHAT FAILED DEFENCE COSTS</a:t>
-            </a:r>
-          </a:p>
-        </p:txBody>
-      </p:sp>
-      <p:sp>
-        <p:nvSpPr>
-          <p:cNvPr id="15" name="Rounded Rectangle 14"/>
-          <p:cNvSpPr/>
-          <p:nvPr/>
-        </p:nvSpPr>
-        <p:spPr>
-          <a:xfrm>
-            <a:off x="6309360" y="1600200"/>
-            <a:ext cx="5330952" cy="1097280"/>
+            <a:off x="548640" y="3200400"/>
+            <a:ext cx="5486400" cy="1417320"/>
           </a:xfrm>
           <a:prstGeom prst="roundRect">
             <a:avLst>
-              <a:gd name="adj" fmla="val 8000"/>
+              <a:gd name="adj" fmla="val 6000"/>
             </a:avLst>
           </a:prstGeom>
           <a:solidFill>
@@ -3874,14 +3642,14 @@
       </p:sp>
       <p:sp>
         <p:nvSpPr>
-          <p:cNvPr id="16" name="TextBox 15"/>
+          <p:cNvPr id="9" name="TextBox 8"/>
           <p:cNvSpPr txBox="1"/>
           <p:nvPr/>
         </p:nvSpPr>
         <p:spPr>
           <a:xfrm>
-            <a:off x="6537960" y="1600200"/>
-            <a:ext cx="2103120" cy="1097280"/>
+            <a:off x="777240" y="3310128"/>
+            <a:ext cx="3657600" cy="228600"/>
           </a:xfrm>
           <a:prstGeom prst="rect">
             <a:avLst/>
@@ -3889,34 +3657,34 @@
           <a:noFill/>
         </p:spPr>
         <p:txBody>
-          <a:bodyPr wrap="square" lIns="0" tIns="0" rIns="0" bIns="0" anchor="ctr">
+          <a:bodyPr wrap="square" lIns="0" tIns="0" rIns="0" bIns="0" anchor="t">
             <a:spAutoFit/>
           </a:bodyPr>
           <a:lstStyle/>
           <a:p>
             <a:pPr algn="l"/>
             <a:r>
-              <a:rPr sz="3200" b="1" i="0">
+              <a:rPr sz="1100" b="1" i="0" spc="120">
                 <a:solidFill>
                   <a:srgbClr val="F2A900"/>
                 </a:solidFill>
-                <a:latin typeface="Cambria"/>
-              </a:rPr>
-              <a:t>$4.99M</a:t>
-            </a:r>
-          </a:p>
-        </p:txBody>
-      </p:sp>
-      <p:sp>
-        <p:nvSpPr>
-          <p:cNvPr id="17" name="TextBox 16"/>
+                <a:latin typeface="Calibri"/>
+              </a:rPr>
+              <a:t>PAPER UNDER REVIEW</a:t>
+            </a:r>
+          </a:p>
+        </p:txBody>
+      </p:sp>
+      <p:sp>
+        <p:nvSpPr>
+          <p:cNvPr id="10" name="TextBox 9"/>
           <p:cNvSpPr txBox="1"/>
           <p:nvPr/>
         </p:nvSpPr>
         <p:spPr>
           <a:xfrm>
-            <a:off x="8686800" y="1709928"/>
-            <a:ext cx="2423160" cy="877824"/>
+            <a:off x="777240" y="3566160"/>
+            <a:ext cx="4937760" cy="502920"/>
           </a:xfrm>
           <a:prstGeom prst="rect">
             <a:avLst/>
@@ -3924,35 +3692,105 @@
           <a:noFill/>
         </p:spPr>
         <p:txBody>
-          <a:bodyPr wrap="square" lIns="0" tIns="0" rIns="0" bIns="0" anchor="ctr">
+          <a:bodyPr wrap="square" lIns="0" tIns="0" rIns="0" bIns="0" anchor="t">
             <a:spAutoFit/>
           </a:bodyPr>
           <a:lstStyle/>
           <a:p>
             <a:pPr algn="l"/>
             <a:r>
-              <a:rPr sz="1400" b="0" i="0">
+              <a:rPr sz="1400" b="1" i="0">
                 <a:solidFill>
                   <a:srgbClr val="FFFFFF"/>
                 </a:solidFill>
                 <a:latin typeface="Calibri"/>
               </a:rPr>
-              <a:t>average cost of one data breach worldwide, a record (+12%)</a:t>
-            </a:r>
-          </a:p>
-        </p:txBody>
-      </p:sp>
-      <p:sp>
-        <p:nvSpPr>
-          <p:cNvPr id="18" name="ref-2">
-            <a:hlinkClick r:id="rId4"/>
+              <a:t>Anomaly Detection in Network Traffic Using Advanced Machine Learning Techniques</a:t>
+            </a:r>
+          </a:p>
+        </p:txBody>
+      </p:sp>
+      <p:sp>
+        <p:nvSpPr>
+          <p:cNvPr id="11" name="TextBox 10"/>
+          <p:cNvSpPr txBox="1"/>
+          <p:nvPr/>
+        </p:nvSpPr>
+        <p:spPr>
+          <a:xfrm>
+            <a:off x="777240" y="4114800"/>
+            <a:ext cx="5029200" cy="228600"/>
+          </a:xfrm>
+          <a:prstGeom prst="rect">
+            <a:avLst/>
+          </a:prstGeom>
+          <a:noFill/>
+        </p:spPr>
+        <p:txBody>
+          <a:bodyPr wrap="square" lIns="0" tIns="0" rIns="0" bIns="0" anchor="t">
+            <a:spAutoFit/>
+          </a:bodyPr>
+          <a:lstStyle/>
+          <a:p>
+            <a:pPr algn="l"/>
+            <a:r>
+              <a:rPr sz="1200" b="0" i="0">
+                <a:solidFill>
+                  <a:srgbClr val="9FB3CC"/>
+                </a:solidFill>
+                <a:latin typeface="Calibri"/>
+              </a:rPr>
+              <a:t>S. Ness et al.  ·  IEEE Access, vol. 13, pp. 16133–16149, 2025</a:t>
+            </a:r>
+          </a:p>
+        </p:txBody>
+      </p:sp>
+      <p:sp>
+        <p:nvSpPr>
+          <p:cNvPr id="12" name="TextBox 11"/>
+          <p:cNvSpPr txBox="1"/>
+          <p:nvPr/>
+        </p:nvSpPr>
+        <p:spPr>
+          <a:xfrm>
+            <a:off x="777240" y="4361688"/>
+            <a:ext cx="4572000" cy="228600"/>
+          </a:xfrm>
+          <a:prstGeom prst="rect">
+            <a:avLst/>
+          </a:prstGeom>
+          <a:noFill/>
+        </p:spPr>
+        <p:txBody>
+          <a:bodyPr wrap="square" lIns="0" tIns="0" rIns="0" bIns="0" anchor="t">
+            <a:spAutoFit/>
+          </a:bodyPr>
+          <a:lstStyle/>
+          <a:p>
+            <a:pPr algn="l"/>
+            <a:r>
+              <a:rPr sz="1200" b="1" i="0">
+                <a:solidFill>
+                  <a:srgbClr val="FFFFFF"/>
+                </a:solidFill>
+                <a:latin typeface="Calibri"/>
+              </a:rPr>
+              <a:t>Paper number (DOI)  10.1109/ACCESS.2025.3526988</a:t>
+            </a:r>
+          </a:p>
+        </p:txBody>
+      </p:sp>
+      <p:sp>
+        <p:nvSpPr>
+          <p:cNvPr id="13" name="ref-1">
+            <a:hlinkClick r:id="rId3"/>
           </p:cNvPr>
           <p:cNvSpPr/>
           <p:nvPr/>
         </p:nvSpPr>
         <p:spPr>
           <a:xfrm>
-            <a:off x="11155680" y="2020824"/>
+            <a:off x="5532120" y="3310128"/>
             <a:ext cx="402336" cy="256032"/>
           </a:xfrm>
           <a:prstGeom prst="roundRect">
@@ -3996,20 +3834,158 @@
                 </a:solidFill>
                 <a:latin typeface="Calibri"/>
               </a:rPr>
-              <a:t>[2]</a:t>
-            </a:r>
-          </a:p>
-        </p:txBody>
-      </p:sp>
-      <p:sp>
-        <p:nvSpPr>
-          <p:cNvPr id="19" name="Rounded Rectangle 18"/>
+              <a:t>[1]</a:t>
+            </a:r>
+          </a:p>
+        </p:txBody>
+      </p:sp>
+      <p:sp>
+        <p:nvSpPr>
+          <p:cNvPr id="14" name="icon-bg-warning"/>
           <p:cNvSpPr/>
           <p:nvPr/>
         </p:nvSpPr>
         <p:spPr>
           <a:xfrm>
-            <a:off x="6309360" y="2834640"/>
+            <a:off x="548640" y="4754880"/>
+            <a:ext cx="420624" cy="420624"/>
+          </a:xfrm>
+          <a:prstGeom prst="ellipse">
+            <a:avLst/>
+          </a:prstGeom>
+          <a:solidFill>
+            <a:srgbClr val="2D7FD3"/>
+          </a:solidFill>
+          <a:ln>
+            <a:noFill/>
+          </a:ln>
+          <a:effectLst/>
+        </p:spPr>
+        <p:style>
+          <a:lnRef idx="1">
+            <a:schemeClr val="accent1"/>
+          </a:lnRef>
+          <a:fillRef idx="3">
+            <a:schemeClr val="accent1"/>
+          </a:fillRef>
+          <a:effectRef idx="2">
+            <a:schemeClr val="accent1"/>
+          </a:effectRef>
+          <a:fontRef idx="minor">
+            <a:schemeClr val="lt1"/>
+          </a:fontRef>
+        </p:style>
+        <p:txBody>
+          <a:bodyPr rtlCol="0" anchor="ctr"/>
+          <a:lstStyle/>
+          <a:p>
+            <a:pPr algn="ctr"/>
+          </a:p>
+        </p:txBody>
+      </p:sp>
+      <p:pic>
+        <p:nvPicPr>
+          <p:cNvPr id="15" name="icon-warning" descr="warning icon"/>
+          <p:cNvPicPr>
+            <a:picLocks noChangeAspect="1"/>
+          </p:cNvPicPr>
+          <p:nvPr/>
+        </p:nvPicPr>
+        <p:blipFill>
+          <a:blip r:embed="rId4"/>
+          <a:stretch>
+            <a:fillRect/>
+          </a:stretch>
+        </p:blipFill>
+        <p:spPr>
+          <a:xfrm>
+            <a:off x="636971" y="4843211"/>
+            <a:ext cx="243961" cy="243961"/>
+          </a:xfrm>
+          <a:prstGeom prst="rect">
+            <a:avLst/>
+          </a:prstGeom>
+        </p:spPr>
+      </p:pic>
+      <p:sp>
+        <p:nvSpPr>
+          <p:cNvPr id="16" name="TextBox 15"/>
+          <p:cNvSpPr txBox="1"/>
+          <p:nvPr/>
+        </p:nvSpPr>
+        <p:spPr>
+          <a:xfrm>
+            <a:off x="1097280" y="4681728"/>
+            <a:ext cx="4937760" cy="566928"/>
+          </a:xfrm>
+          <a:prstGeom prst="rect">
+            <a:avLst/>
+          </a:prstGeom>
+          <a:noFill/>
+        </p:spPr>
+        <p:txBody>
+          <a:bodyPr wrap="square" lIns="0" tIns="0" rIns="0" bIns="0" anchor="ctr">
+            <a:spAutoFit/>
+          </a:bodyPr>
+          <a:lstStyle/>
+          <a:p>
+            <a:pPr algn="l"/>
+            <a:r>
+              <a:rPr sz="1400" b="0" i="0">
+                <a:solidFill>
+                  <a:srgbClr val="FFFFFF"/>
+                </a:solidFill>
+                <a:latin typeface="Calibri"/>
+              </a:rPr>
+              <a:t>A missed attack costs money. A false alarm wastes analysts' time.</a:t>
+            </a:r>
+          </a:p>
+        </p:txBody>
+      </p:sp>
+      <p:sp>
+        <p:nvSpPr>
+          <p:cNvPr id="17" name="TextBox 16"/>
+          <p:cNvSpPr txBox="1"/>
+          <p:nvPr/>
+        </p:nvSpPr>
+        <p:spPr>
+          <a:xfrm>
+            <a:off x="6309360" y="1188720"/>
+            <a:ext cx="5303520" cy="274320"/>
+          </a:xfrm>
+          <a:prstGeom prst="rect">
+            <a:avLst/>
+          </a:prstGeom>
+          <a:noFill/>
+        </p:spPr>
+        <p:txBody>
+          <a:bodyPr wrap="square" lIns="0" tIns="0" rIns="0" bIns="0" anchor="t">
+            <a:spAutoFit/>
+          </a:bodyPr>
+          <a:lstStyle/>
+          <a:p>
+            <a:pPr algn="l"/>
+            <a:r>
+              <a:rPr sz="1200" b="1" i="0" spc="120">
+                <a:solidFill>
+                  <a:srgbClr val="F2A900"/>
+                </a:solidFill>
+                <a:latin typeface="Calibri"/>
+              </a:rPr>
+              <a:t>INDUSTRY LOSS  ·  WHAT FAILED DEFENCE COSTS</a:t>
+            </a:r>
+          </a:p>
+        </p:txBody>
+      </p:sp>
+      <p:sp>
+        <p:nvSpPr>
+          <p:cNvPr id="18" name="Rounded Rectangle 17"/>
+          <p:cNvSpPr/>
+          <p:nvPr/>
+        </p:nvSpPr>
+        <p:spPr>
+          <a:xfrm>
+            <a:off x="6309360" y="1600200"/>
             <a:ext cx="5330952" cy="1097280"/>
           </a:xfrm>
           <a:prstGeom prst="roundRect">
@@ -4049,13 +4025,13 @@
       </p:sp>
       <p:sp>
         <p:nvSpPr>
-          <p:cNvPr id="20" name="TextBox 19"/>
+          <p:cNvPr id="19" name="TextBox 18"/>
           <p:cNvSpPr txBox="1"/>
           <p:nvPr/>
         </p:nvSpPr>
         <p:spPr>
           <a:xfrm>
-            <a:off x="6537960" y="2834640"/>
+            <a:off x="6537960" y="1600200"/>
             <a:ext cx="2103120" cy="1097280"/>
           </a:xfrm>
           <a:prstGeom prst="rect">
@@ -4077,20 +4053,20 @@
                 </a:solidFill>
                 <a:latin typeface="Cambria"/>
               </a:rPr>
-              <a:t>247 days</a:t>
-            </a:r>
-          </a:p>
-        </p:txBody>
-      </p:sp>
-      <p:sp>
-        <p:nvSpPr>
-          <p:cNvPr id="21" name="TextBox 20"/>
+              <a:t>$4.99M</a:t>
+            </a:r>
+          </a:p>
+        </p:txBody>
+      </p:sp>
+      <p:sp>
+        <p:nvSpPr>
+          <p:cNvPr id="20" name="TextBox 19"/>
           <p:cNvSpPr txBox="1"/>
           <p:nvPr/>
         </p:nvSpPr>
         <p:spPr>
           <a:xfrm>
-            <a:off x="8686800" y="2944368"/>
+            <a:off x="8686800" y="1709928"/>
             <a:ext cx="2423160" cy="877824"/>
           </a:xfrm>
           <a:prstGeom prst="rect">
@@ -4112,22 +4088,22 @@
                 </a:solidFill>
                 <a:latin typeface="Calibri"/>
               </a:rPr>
-              <a:t>average time to find and contain a breach</a:t>
-            </a:r>
-          </a:p>
-        </p:txBody>
-      </p:sp>
-      <p:sp>
-        <p:nvSpPr>
-          <p:cNvPr id="22" name="ref-2">
-            <a:hlinkClick r:id="rId4"/>
+              <a:t>average cost of one data breach worldwide, a record (+12%)</a:t>
+            </a:r>
+          </a:p>
+        </p:txBody>
+      </p:sp>
+      <p:sp>
+        <p:nvSpPr>
+          <p:cNvPr id="21" name="ref-2">
+            <a:hlinkClick r:id="rId5"/>
           </p:cNvPr>
           <p:cNvSpPr/>
           <p:nvPr/>
         </p:nvSpPr>
         <p:spPr>
           <a:xfrm>
-            <a:off x="11155680" y="3255264"/>
+            <a:off x="11155680" y="2020824"/>
             <a:ext cx="402336" cy="256032"/>
           </a:xfrm>
           <a:prstGeom prst="roundRect">
@@ -4178,13 +4154,13 @@
       </p:sp>
       <p:sp>
         <p:nvSpPr>
-          <p:cNvPr id="23" name="Rounded Rectangle 22"/>
+          <p:cNvPr id="22" name="Rounded Rectangle 21"/>
           <p:cNvSpPr/>
           <p:nvPr/>
         </p:nvSpPr>
         <p:spPr>
           <a:xfrm>
-            <a:off x="6309360" y="4069080"/>
+            <a:off x="6309360" y="2834640"/>
             <a:ext cx="5330952" cy="1097280"/>
           </a:xfrm>
           <a:prstGeom prst="roundRect">
@@ -4224,13 +4200,13 @@
       </p:sp>
       <p:sp>
         <p:nvSpPr>
-          <p:cNvPr id="24" name="TextBox 23"/>
+          <p:cNvPr id="23" name="TextBox 22"/>
           <p:cNvSpPr txBox="1"/>
           <p:nvPr/>
         </p:nvSpPr>
         <p:spPr>
           <a:xfrm>
-            <a:off x="6537960" y="4069080"/>
+            <a:off x="6537960" y="2834640"/>
             <a:ext cx="2103120" cy="1097280"/>
           </a:xfrm>
           <a:prstGeom prst="rect">
@@ -4252,20 +4228,20 @@
                 </a:solidFill>
                 <a:latin typeface="Cambria"/>
               </a:rPr>
-              <a:t>$20.9B</a:t>
-            </a:r>
-          </a:p>
-        </p:txBody>
-      </p:sp>
-      <p:sp>
-        <p:nvSpPr>
-          <p:cNvPr id="25" name="TextBox 24"/>
+              <a:t>247 days</a:t>
+            </a:r>
+          </a:p>
+        </p:txBody>
+      </p:sp>
+      <p:sp>
+        <p:nvSpPr>
+          <p:cNvPr id="24" name="TextBox 23"/>
           <p:cNvSpPr txBox="1"/>
           <p:nvPr/>
         </p:nvSpPr>
         <p:spPr>
           <a:xfrm>
-            <a:off x="8686800" y="4178808"/>
+            <a:off x="8686800" y="2944368"/>
             <a:ext cx="2423160" cy="877824"/>
           </a:xfrm>
           <a:prstGeom prst="rect">
@@ -4287,14 +4263,14 @@
                 </a:solidFill>
                 <a:latin typeface="Calibri"/>
               </a:rPr>
-              <a:t>cybercrime losses reported to the FBI in 2025 (+26%)</a:t>
-            </a:r>
-          </a:p>
-        </p:txBody>
-      </p:sp>
-      <p:sp>
-        <p:nvSpPr>
-          <p:cNvPr id="26" name="ref-3">
+              <a:t>average time to find and contain a breach</a:t>
+            </a:r>
+          </a:p>
+        </p:txBody>
+      </p:sp>
+      <p:sp>
+        <p:nvSpPr>
+          <p:cNvPr id="25" name="ref-2">
             <a:hlinkClick r:id="rId5"/>
           </p:cNvPr>
           <p:cNvSpPr/>
@@ -4302,7 +4278,7 @@
         </p:nvSpPr>
         <p:spPr>
           <a:xfrm>
-            <a:off x="11155680" y="4489704"/>
+            <a:off x="11155680" y="3255264"/>
             <a:ext cx="402336" cy="256032"/>
           </a:xfrm>
           <a:prstGeom prst="roundRect">
@@ -4346,6 +4322,181 @@
                 </a:solidFill>
                 <a:latin typeface="Calibri"/>
               </a:rPr>
+              <a:t>[2]</a:t>
+            </a:r>
+          </a:p>
+        </p:txBody>
+      </p:sp>
+      <p:sp>
+        <p:nvSpPr>
+          <p:cNvPr id="26" name="Rounded Rectangle 25"/>
+          <p:cNvSpPr/>
+          <p:nvPr/>
+        </p:nvSpPr>
+        <p:spPr>
+          <a:xfrm>
+            <a:off x="6309360" y="4069080"/>
+            <a:ext cx="5330952" cy="1097280"/>
+          </a:xfrm>
+          <a:prstGeom prst="roundRect">
+            <a:avLst>
+              <a:gd name="adj" fmla="val 8000"/>
+            </a:avLst>
+          </a:prstGeom>
+          <a:solidFill>
+            <a:srgbClr val="132F55"/>
+          </a:solidFill>
+          <a:ln>
+            <a:noFill/>
+          </a:ln>
+          <a:effectLst/>
+        </p:spPr>
+        <p:style>
+          <a:lnRef idx="1">
+            <a:schemeClr val="accent1"/>
+          </a:lnRef>
+          <a:fillRef idx="3">
+            <a:schemeClr val="accent1"/>
+          </a:fillRef>
+          <a:effectRef idx="2">
+            <a:schemeClr val="accent1"/>
+          </a:effectRef>
+          <a:fontRef idx="minor">
+            <a:schemeClr val="lt1"/>
+          </a:fontRef>
+        </p:style>
+        <p:txBody>
+          <a:bodyPr rtlCol="0" anchor="ctr"/>
+          <a:lstStyle/>
+          <a:p>
+            <a:pPr algn="ctr"/>
+          </a:p>
+        </p:txBody>
+      </p:sp>
+      <p:sp>
+        <p:nvSpPr>
+          <p:cNvPr id="27" name="TextBox 26"/>
+          <p:cNvSpPr txBox="1"/>
+          <p:nvPr/>
+        </p:nvSpPr>
+        <p:spPr>
+          <a:xfrm>
+            <a:off x="6537960" y="4069080"/>
+            <a:ext cx="2103120" cy="1097280"/>
+          </a:xfrm>
+          <a:prstGeom prst="rect">
+            <a:avLst/>
+          </a:prstGeom>
+          <a:noFill/>
+        </p:spPr>
+        <p:txBody>
+          <a:bodyPr wrap="square" lIns="0" tIns="0" rIns="0" bIns="0" anchor="ctr">
+            <a:spAutoFit/>
+          </a:bodyPr>
+          <a:lstStyle/>
+          <a:p>
+            <a:pPr algn="l"/>
+            <a:r>
+              <a:rPr sz="3200" b="1" i="0">
+                <a:solidFill>
+                  <a:srgbClr val="F2A900"/>
+                </a:solidFill>
+                <a:latin typeface="Cambria"/>
+              </a:rPr>
+              <a:t>$20.9B</a:t>
+            </a:r>
+          </a:p>
+        </p:txBody>
+      </p:sp>
+      <p:sp>
+        <p:nvSpPr>
+          <p:cNvPr id="28" name="TextBox 27"/>
+          <p:cNvSpPr txBox="1"/>
+          <p:nvPr/>
+        </p:nvSpPr>
+        <p:spPr>
+          <a:xfrm>
+            <a:off x="8686800" y="4178808"/>
+            <a:ext cx="2423160" cy="877824"/>
+          </a:xfrm>
+          <a:prstGeom prst="rect">
+            <a:avLst/>
+          </a:prstGeom>
+          <a:noFill/>
+        </p:spPr>
+        <p:txBody>
+          <a:bodyPr wrap="square" lIns="0" tIns="0" rIns="0" bIns="0" anchor="ctr">
+            <a:spAutoFit/>
+          </a:bodyPr>
+          <a:lstStyle/>
+          <a:p>
+            <a:pPr algn="l"/>
+            <a:r>
+              <a:rPr sz="1400" b="0" i="0">
+                <a:solidFill>
+                  <a:srgbClr val="FFFFFF"/>
+                </a:solidFill>
+                <a:latin typeface="Calibri"/>
+              </a:rPr>
+              <a:t>cybercrime losses reported to the FBI in 2025 (+26%)</a:t>
+            </a:r>
+          </a:p>
+        </p:txBody>
+      </p:sp>
+      <p:sp>
+        <p:nvSpPr>
+          <p:cNvPr id="29" name="ref-3">
+            <a:hlinkClick r:id="rId6"/>
+          </p:cNvPr>
+          <p:cNvSpPr/>
+          <p:nvPr/>
+        </p:nvSpPr>
+        <p:spPr>
+          <a:xfrm>
+            <a:off x="11155680" y="4489704"/>
+            <a:ext cx="402336" cy="256032"/>
+          </a:xfrm>
+          <a:prstGeom prst="roundRect">
+            <a:avLst>
+              <a:gd name="adj" fmla="val 50000"/>
+            </a:avLst>
+          </a:prstGeom>
+          <a:solidFill>
+            <a:srgbClr val="FFFFFF"/>
+          </a:solidFill>
+          <a:ln w="9525">
+            <a:solidFill>
+              <a:srgbClr val="0B5CAD"/>
+            </a:solidFill>
+          </a:ln>
+          <a:effectLst/>
+        </p:spPr>
+        <p:style>
+          <a:lnRef idx="1">
+            <a:schemeClr val="accent1"/>
+          </a:lnRef>
+          <a:fillRef idx="3">
+            <a:schemeClr val="accent1"/>
+          </a:fillRef>
+          <a:effectRef idx="2">
+            <a:schemeClr val="accent1"/>
+          </a:effectRef>
+          <a:fontRef idx="minor">
+            <a:schemeClr val="lt1"/>
+          </a:fontRef>
+        </p:style>
+        <p:txBody>
+          <a:bodyPr rtlCol="0" anchor="ctr" wrap="square" lIns="0" tIns="0" rIns="0" bIns="0"/>
+          <a:lstStyle/>
+          <a:p>
+            <a:pPr algn="ctr"/>
+            <a:r>
+              <a:rPr sz="1100" b="1" i="0">
+                <a:solidFill>
+                  <a:srgbClr val="0B5CAD"/>
+                </a:solidFill>
+                <a:latin typeface="Calibri"/>
+              </a:rPr>
               <a:t>[3]</a:t>
             </a:r>
           </a:p>
@@ -4353,7 +4504,7 @@
       </p:sp>
       <p:sp>
         <p:nvSpPr>
-          <p:cNvPr id="27" name="question-bar"/>
+          <p:cNvPr id="30" name="question-bar"/>
           <p:cNvSpPr/>
           <p:nvPr/>
         </p:nvSpPr>
@@ -4417,7 +4568,7 @@
       </p:sp>
       <p:sp>
         <p:nvSpPr>
-          <p:cNvPr id="28" name="footer"/>
+          <p:cNvPr id="31" name="footer"/>
           <p:cNvSpPr txBox="1"/>
           <p:nvPr/>
         </p:nvSpPr>
@@ -4452,8 +4603,8 @@
       </p:sp>
       <p:sp>
         <p:nvSpPr>
-          <p:cNvPr id="29" name="nav-1">
-            <a:hlinkClick action="ppaction://hlinksldjump" r:id="rId6"/>
+          <p:cNvPr id="32" name="nav-1">
+            <a:hlinkClick action="ppaction://hlinksldjump" r:id="rId7"/>
           </p:cNvPr>
           <p:cNvSpPr/>
           <p:nvPr/>
@@ -4507,8 +4658,8 @@
       </p:sp>
       <p:sp>
         <p:nvSpPr>
-          <p:cNvPr id="30" name="nav-2">
-            <a:hlinkClick action="ppaction://hlinksldjump" r:id="rId7"/>
+          <p:cNvPr id="33" name="nav-2">
+            <a:hlinkClick action="ppaction://hlinksldjump" r:id="rId8"/>
           </p:cNvPr>
           <p:cNvSpPr/>
           <p:nvPr/>
@@ -4562,8 +4713,8 @@
       </p:sp>
       <p:sp>
         <p:nvSpPr>
-          <p:cNvPr id="31" name="nav-3">
-            <a:hlinkClick action="ppaction://hlinksldjump" r:id="rId8"/>
+          <p:cNvPr id="34" name="nav-3">
+            <a:hlinkClick action="ppaction://hlinksldjump" r:id="rId9"/>
           </p:cNvPr>
           <p:cNvSpPr/>
           <p:nvPr/>
@@ -4617,8 +4768,8 @@
       </p:sp>
       <p:sp>
         <p:nvSpPr>
-          <p:cNvPr id="32" name="nav-4">
-            <a:hlinkClick action="ppaction://hlinksldjump" r:id="rId9"/>
+          <p:cNvPr id="35" name="nav-4">
+            <a:hlinkClick action="ppaction://hlinksldjump" r:id="rId10"/>
           </p:cNvPr>
           <p:cNvSpPr/>
           <p:nvPr/>
@@ -4672,8 +4823,8 @@
       </p:sp>
       <p:sp>
         <p:nvSpPr>
-          <p:cNvPr id="33" name="nav-5">
-            <a:hlinkClick action="ppaction://hlinksldjump" r:id="rId10"/>
+          <p:cNvPr id="36" name="nav-5">
+            <a:hlinkClick action="ppaction://hlinksldjump" r:id="rId11"/>
           </p:cNvPr>
           <p:cNvSpPr/>
           <p:nvPr/>
@@ -4727,8 +4878,8 @@
       </p:sp>
       <p:sp>
         <p:nvSpPr>
-          <p:cNvPr id="34" name="nav-6">
-            <a:hlinkClick action="ppaction://hlinksldjump" r:id="rId11"/>
+          <p:cNvPr id="37" name="nav-6">
+            <a:hlinkClick action="ppaction://hlinksldjump" r:id="rId12"/>
           </p:cNvPr>
           <p:cNvSpPr/>
           <p:nvPr/>

</xml_diff>

<commit_message>
Rework title slide and split slide 3 into paper vs industry loss
Slide 1 is now a hackathon-style title page with labelled fields (problem
title, IEEE paper, paper number incl. IEEE Xplore 10833631 and DOI, team
members) and no statistics. The "Can 100% accuracy be trusted?" hook moves
to slide 3, which is a split screen: the paper's bar graphs on the left and
industry loss on the right. Notes updated.

Co-Authored-By: Claude Sonnet 5.5 <noreply@anthropic.com>
Claude-Session: https://claude.ai/code/session_011j42H134gDyTK6hHhsp5dc
</commit_message>
<xml_diff>
--- a/beyond-100/Beyond_100.pptx
+++ b/beyond-100/Beyond_100.pptx
@@ -300,7 +300,7 @@
           <c:showBubbleSize val="0"/>
           <c:showLeaderLines val="1"/>
         </c:dLbls>
-        <c:gapWidth val="60"/>
+        <c:gapWidth val="55"/>
         <c:overlap val="-5"/>
         <c:axId val="-2068027336"/>
         <c:axId val="-2113994440"/>
@@ -3390,8 +3390,8 @@
         </p:nvSpPr>
         <p:spPr>
           <a:xfrm>
-            <a:off x="548640" y="1554480"/>
-            <a:ext cx="5577840" cy="1600200"/>
+            <a:off x="548640" y="1097280"/>
+            <a:ext cx="6949440" cy="1005840"/>
           </a:xfrm>
         </p:spPr>
         <p:txBody>
@@ -3400,14 +3400,13 @@
           <a:p>
             <a:pPr algn="l"/>
             <a:r>
-              <a:rPr sz="4600" b="1" i="0">
+              <a:rPr sz="6000" b="1" i="0">
                 <a:solidFill>
                   <a:srgbClr val="FFFFFF"/>
                 </a:solidFill>
                 <a:latin typeface="Cambria"/>
               </a:rPr>
-              <a:t>Can 100% Accuracy
-Be Trusted?</a:t>
+              <a:t>Beyond 100%</a:t>
             </a:r>
           </a:p>
         </p:txBody>
@@ -3489,7 +3488,7 @@
         <p:spPr>
           <a:xfrm>
             <a:off x="1143000" y="384048"/>
-            <a:ext cx="3657600" cy="457200"/>
+            <a:ext cx="5486400" cy="457200"/>
           </a:xfrm>
           <a:prstGeom prst="rect">
             <a:avLst/>
@@ -3504,27 +3503,27 @@
           <a:p>
             <a:pPr algn="l"/>
             <a:r>
-              <a:rPr sz="1600" b="1" i="0" spc="200">
+              <a:rPr sz="1500" b="1" i="0" spc="200">
                 <a:solidFill>
                   <a:srgbClr val="FFFFFF"/>
                 </a:solidFill>
                 <a:latin typeface="Calibri"/>
               </a:rPr>
-              <a:t>BEYOND 100%</a:t>
-            </a:r>
-          </a:p>
-        </p:txBody>
-      </p:sp>
-      <p:sp>
-        <p:nvSpPr>
-          <p:cNvPr id="6" name="team"/>
+              <a:t>IEEE PAPER PRESENTATION</a:t>
+            </a:r>
+          </a:p>
+        </p:txBody>
+      </p:sp>
+      <p:sp>
+        <p:nvSpPr>
+          <p:cNvPr id="6" name="TextBox 5"/>
           <p:cNvSpPr txBox="1"/>
           <p:nvPr/>
         </p:nvSpPr>
         <p:spPr>
           <a:xfrm>
-            <a:off x="5852160" y="384048"/>
-            <a:ext cx="5788152" cy="457200"/>
+            <a:off x="548640" y="2103120"/>
+            <a:ext cx="6949440" cy="457200"/>
           </a:xfrm>
           <a:prstGeom prst="rect">
             <a:avLst/>
@@ -3537,38 +3536,968 @@
           </a:bodyPr>
           <a:lstStyle/>
           <a:p>
-            <a:pPr algn="r"/>
-            <a:r>
-              <a:rPr sz="1100" b="1" i="0" spc="120">
-                <a:solidFill>
-                  <a:srgbClr val="F2A900"/>
-                </a:solidFill>
-                <a:latin typeface="Calibri"/>
-              </a:rPr>
-              <a:t>TEAM   </a:t>
-            </a:r>
-            <a:r>
-              <a:rPr sz="1600" b="1" i="0">
-                <a:solidFill>
-                  <a:srgbClr val="FFFFFF"/>
-                </a:solidFill>
-                <a:latin typeface="Calibri"/>
-              </a:rPr>
-              <a:t>Mahidhar  ·  Sasikanth  ·  Harshith</a:t>
-            </a:r>
-          </a:p>
-        </p:txBody>
-      </p:sp>
-      <p:sp>
-        <p:nvSpPr>
-          <p:cNvPr id="7" name="kicker"/>
+            <a:pPr algn="l"/>
+            <a:r>
+              <a:rPr sz="2200" b="0" i="1">
+                <a:solidFill>
+                  <a:srgbClr val="9FB3CC"/>
+                </a:solidFill>
+                <a:latin typeface="Cambria"/>
+              </a:rPr>
+              <a:t>From high accuracy to reliable detection</a:t>
+            </a:r>
+          </a:p>
+        </p:txBody>
+      </p:sp>
+      <p:cxnSp>
+        <p:nvCxnSpPr>
+          <p:cNvPr id="7" name="network-edge"/>
+          <p:cNvCxnSpPr/>
+          <p:nvPr/>
+        </p:nvCxnSpPr>
+        <p:spPr>
+          <a:xfrm flipV="1">
+            <a:off x="8101583" y="1189634"/>
+            <a:ext cx="512065" cy="659740"/>
+          </a:xfrm>
+          <a:prstGeom prst="line">
+            <a:avLst/>
+          </a:prstGeom>
+          <a:ln w="15875">
+            <a:solidFill>
+              <a:srgbClr val="1B4A82"/>
+            </a:solidFill>
+          </a:ln>
+        </p:spPr>
+        <p:style>
+          <a:lnRef idx="2">
+            <a:schemeClr val="accent1"/>
+          </a:lnRef>
+          <a:fillRef idx="0">
+            <a:schemeClr val="accent1"/>
+          </a:fillRef>
+          <a:effectRef idx="1">
+            <a:schemeClr val="accent1"/>
+          </a:effectRef>
+          <a:fontRef idx="minor">
+            <a:schemeClr val="tx1"/>
+          </a:fontRef>
+        </p:style>
+      </p:cxnSp>
+      <p:cxnSp>
+        <p:nvCxnSpPr>
+          <p:cNvPr id="8" name="network-edge"/>
+          <p:cNvCxnSpPr/>
+          <p:nvPr/>
+        </p:nvCxnSpPr>
+        <p:spPr>
+          <a:xfrm>
+            <a:off x="8101583" y="1849374"/>
+            <a:ext cx="841249" cy="410108"/>
+          </a:xfrm>
+          <a:prstGeom prst="line">
+            <a:avLst/>
+          </a:prstGeom>
+          <a:ln w="15875">
+            <a:solidFill>
+              <a:srgbClr val="1B4A82"/>
+            </a:solidFill>
+          </a:ln>
+        </p:spPr>
+        <p:style>
+          <a:lnRef idx="2">
+            <a:schemeClr val="accent1"/>
+          </a:lnRef>
+          <a:fillRef idx="0">
+            <a:schemeClr val="accent1"/>
+          </a:fillRef>
+          <a:effectRef idx="1">
+            <a:schemeClr val="accent1"/>
+          </a:effectRef>
+          <a:fontRef idx="minor">
+            <a:schemeClr val="tx1"/>
+          </a:fontRef>
+        </p:style>
+      </p:cxnSp>
+      <p:cxnSp>
+        <p:nvCxnSpPr>
+          <p:cNvPr id="9" name="network-edge"/>
+          <p:cNvCxnSpPr/>
+          <p:nvPr/>
+        </p:nvCxnSpPr>
+        <p:spPr>
+          <a:xfrm>
+            <a:off x="8613648" y="1189634"/>
+            <a:ext cx="950976" cy="427939"/>
+          </a:xfrm>
+          <a:prstGeom prst="line">
+            <a:avLst/>
+          </a:prstGeom>
+          <a:ln w="15875">
+            <a:solidFill>
+              <a:srgbClr val="1B4A82"/>
+            </a:solidFill>
+          </a:ln>
+        </p:spPr>
+        <p:style>
+          <a:lnRef idx="2">
+            <a:schemeClr val="accent1"/>
+          </a:lnRef>
+          <a:fillRef idx="0">
+            <a:schemeClr val="accent1"/>
+          </a:fillRef>
+          <a:effectRef idx="1">
+            <a:schemeClr val="accent1"/>
+          </a:effectRef>
+          <a:fontRef idx="minor">
+            <a:schemeClr val="tx1"/>
+          </a:fontRef>
+        </p:style>
+      </p:cxnSp>
+      <p:cxnSp>
+        <p:nvCxnSpPr>
+          <p:cNvPr id="10" name="network-edge"/>
+          <p:cNvCxnSpPr/>
+          <p:nvPr/>
+        </p:nvCxnSpPr>
+        <p:spPr>
+          <a:xfrm flipV="1">
+            <a:off x="8942832" y="1617573"/>
+            <a:ext cx="621792" cy="641909"/>
+          </a:xfrm>
+          <a:prstGeom prst="line">
+            <a:avLst/>
+          </a:prstGeom>
+          <a:ln w="15875">
+            <a:solidFill>
+              <a:srgbClr val="1B4A82"/>
+            </a:solidFill>
+          </a:ln>
+        </p:spPr>
+        <p:style>
+          <a:lnRef idx="2">
+            <a:schemeClr val="accent1"/>
+          </a:lnRef>
+          <a:fillRef idx="0">
+            <a:schemeClr val="accent1"/>
+          </a:fillRef>
+          <a:effectRef idx="1">
+            <a:schemeClr val="accent1"/>
+          </a:effectRef>
+          <a:fontRef idx="minor">
+            <a:schemeClr val="tx1"/>
+          </a:fontRef>
+        </p:style>
+      </p:cxnSp>
+      <p:cxnSp>
+        <p:nvCxnSpPr>
+          <p:cNvPr id="11" name="network-edge"/>
+          <p:cNvCxnSpPr/>
+          <p:nvPr/>
+        </p:nvCxnSpPr>
+        <p:spPr>
+          <a:xfrm>
+            <a:off x="9564624" y="1617573"/>
+            <a:ext cx="402335" cy="855879"/>
+          </a:xfrm>
+          <a:prstGeom prst="line">
+            <a:avLst/>
+          </a:prstGeom>
+          <a:ln w="15875">
+            <a:solidFill>
+              <a:srgbClr val="1B4A82"/>
+            </a:solidFill>
+          </a:ln>
+        </p:spPr>
+        <p:style>
+          <a:lnRef idx="2">
+            <a:schemeClr val="accent1"/>
+          </a:lnRef>
+          <a:fillRef idx="0">
+            <a:schemeClr val="accent1"/>
+          </a:fillRef>
+          <a:effectRef idx="1">
+            <a:schemeClr val="accent1"/>
+          </a:effectRef>
+          <a:fontRef idx="minor">
+            <a:schemeClr val="tx1"/>
+          </a:fontRef>
+        </p:style>
+      </p:cxnSp>
+      <p:cxnSp>
+        <p:nvCxnSpPr>
+          <p:cNvPr id="12" name="network-edge"/>
+          <p:cNvCxnSpPr/>
+          <p:nvPr/>
+        </p:nvCxnSpPr>
+        <p:spPr>
+          <a:xfrm flipV="1">
+            <a:off x="9564624" y="1082649"/>
+            <a:ext cx="585216" cy="534924"/>
+          </a:xfrm>
+          <a:prstGeom prst="line">
+            <a:avLst/>
+          </a:prstGeom>
+          <a:ln w="15875">
+            <a:solidFill>
+              <a:srgbClr val="1B4A82"/>
+            </a:solidFill>
+          </a:ln>
+        </p:spPr>
+        <p:style>
+          <a:lnRef idx="2">
+            <a:schemeClr val="accent1"/>
+          </a:lnRef>
+          <a:fillRef idx="0">
+            <a:schemeClr val="accent1"/>
+          </a:fillRef>
+          <a:effectRef idx="1">
+            <a:schemeClr val="accent1"/>
+          </a:effectRef>
+          <a:fontRef idx="minor">
+            <a:schemeClr val="tx1"/>
+          </a:fontRef>
+        </p:style>
+      </p:cxnSp>
+      <p:cxnSp>
+        <p:nvCxnSpPr>
+          <p:cNvPr id="13" name="network-edge"/>
+          <p:cNvCxnSpPr/>
+          <p:nvPr/>
+        </p:nvCxnSpPr>
+        <p:spPr>
+          <a:xfrm>
+            <a:off x="9564624" y="1617573"/>
+            <a:ext cx="1170431" cy="231801"/>
+          </a:xfrm>
+          <a:prstGeom prst="line">
+            <a:avLst/>
+          </a:prstGeom>
+          <a:ln w="15875">
+            <a:solidFill>
+              <a:srgbClr val="1B4A82"/>
+            </a:solidFill>
+          </a:ln>
+        </p:spPr>
+        <p:style>
+          <a:lnRef idx="2">
+            <a:schemeClr val="accent1"/>
+          </a:lnRef>
+          <a:fillRef idx="0">
+            <a:schemeClr val="accent1"/>
+          </a:fillRef>
+          <a:effectRef idx="1">
+            <a:schemeClr val="accent1"/>
+          </a:effectRef>
+          <a:fontRef idx="minor">
+            <a:schemeClr val="tx1"/>
+          </a:fontRef>
+        </p:style>
+      </p:cxnSp>
+      <p:cxnSp>
+        <p:nvCxnSpPr>
+          <p:cNvPr id="14" name="network-edge"/>
+          <p:cNvCxnSpPr/>
+          <p:nvPr/>
+        </p:nvCxnSpPr>
+        <p:spPr>
+          <a:xfrm>
+            <a:off x="10149840" y="1082649"/>
+            <a:ext cx="1097279" cy="178308"/>
+          </a:xfrm>
+          <a:prstGeom prst="line">
+            <a:avLst/>
+          </a:prstGeom>
+          <a:ln w="15875">
+            <a:solidFill>
+              <a:srgbClr val="1B4A82"/>
+            </a:solidFill>
+          </a:ln>
+        </p:spPr>
+        <p:style>
+          <a:lnRef idx="2">
+            <a:schemeClr val="accent1"/>
+          </a:lnRef>
+          <a:fillRef idx="0">
+            <a:schemeClr val="accent1"/>
+          </a:fillRef>
+          <a:effectRef idx="1">
+            <a:schemeClr val="accent1"/>
+          </a:effectRef>
+          <a:fontRef idx="minor">
+            <a:schemeClr val="tx1"/>
+          </a:fontRef>
+        </p:style>
+      </p:cxnSp>
+      <p:cxnSp>
+        <p:nvCxnSpPr>
+          <p:cNvPr id="15" name="network-edge"/>
+          <p:cNvCxnSpPr/>
+          <p:nvPr/>
+        </p:nvCxnSpPr>
+        <p:spPr>
+          <a:xfrm flipV="1">
+            <a:off x="10735055" y="1260957"/>
+            <a:ext cx="512064" cy="588417"/>
+          </a:xfrm>
+          <a:prstGeom prst="line">
+            <a:avLst/>
+          </a:prstGeom>
+          <a:ln w="15875">
+            <a:solidFill>
+              <a:srgbClr val="1B4A82"/>
+            </a:solidFill>
+          </a:ln>
+        </p:spPr>
+        <p:style>
+          <a:lnRef idx="2">
+            <a:schemeClr val="accent1"/>
+          </a:lnRef>
+          <a:fillRef idx="0">
+            <a:schemeClr val="accent1"/>
+          </a:fillRef>
+          <a:effectRef idx="1">
+            <a:schemeClr val="accent1"/>
+          </a:effectRef>
+          <a:fontRef idx="minor">
+            <a:schemeClr val="tx1"/>
+          </a:fontRef>
+        </p:style>
+      </p:cxnSp>
+      <p:cxnSp>
+        <p:nvCxnSpPr>
+          <p:cNvPr id="16" name="network-edge"/>
+          <p:cNvCxnSpPr/>
+          <p:nvPr/>
+        </p:nvCxnSpPr>
+        <p:spPr>
+          <a:xfrm>
+            <a:off x="10735055" y="1849374"/>
+            <a:ext cx="658369" cy="445770"/>
+          </a:xfrm>
+          <a:prstGeom prst="line">
+            <a:avLst/>
+          </a:prstGeom>
+          <a:ln w="15875">
+            <a:solidFill>
+              <a:srgbClr val="1B4A82"/>
+            </a:solidFill>
+          </a:ln>
+        </p:spPr>
+        <p:style>
+          <a:lnRef idx="2">
+            <a:schemeClr val="accent1"/>
+          </a:lnRef>
+          <a:fillRef idx="0">
+            <a:schemeClr val="accent1"/>
+          </a:fillRef>
+          <a:effectRef idx="1">
+            <a:schemeClr val="accent1"/>
+          </a:effectRef>
+          <a:fontRef idx="minor">
+            <a:schemeClr val="tx1"/>
+          </a:fontRef>
+        </p:style>
+      </p:cxnSp>
+      <p:cxnSp>
+        <p:nvCxnSpPr>
+          <p:cNvPr id="17" name="network-edge"/>
+          <p:cNvCxnSpPr/>
+          <p:nvPr/>
+        </p:nvCxnSpPr>
+        <p:spPr>
+          <a:xfrm flipV="1">
+            <a:off x="9966959" y="2295144"/>
+            <a:ext cx="1426465" cy="178308"/>
+          </a:xfrm>
+          <a:prstGeom prst="line">
+            <a:avLst/>
+          </a:prstGeom>
+          <a:ln w="15875">
+            <a:solidFill>
+              <a:srgbClr val="1B4A82"/>
+            </a:solidFill>
+          </a:ln>
+        </p:spPr>
+        <p:style>
+          <a:lnRef idx="2">
+            <a:schemeClr val="accent1"/>
+          </a:lnRef>
+          <a:fillRef idx="0">
+            <a:schemeClr val="accent1"/>
+          </a:fillRef>
+          <a:effectRef idx="1">
+            <a:schemeClr val="accent1"/>
+          </a:effectRef>
+          <a:fontRef idx="minor">
+            <a:schemeClr val="tx1"/>
+          </a:fontRef>
+        </p:style>
+      </p:cxnSp>
+      <p:cxnSp>
+        <p:nvCxnSpPr>
+          <p:cNvPr id="18" name="network-edge"/>
+          <p:cNvCxnSpPr/>
+          <p:nvPr/>
+        </p:nvCxnSpPr>
+        <p:spPr>
+          <a:xfrm flipH="1">
+            <a:off x="8321040" y="2259482"/>
+            <a:ext cx="621792" cy="303124"/>
+          </a:xfrm>
+          <a:prstGeom prst="line">
+            <a:avLst/>
+          </a:prstGeom>
+          <a:ln w="15875">
+            <a:solidFill>
+              <a:srgbClr val="1B4A82"/>
+            </a:solidFill>
+          </a:ln>
+        </p:spPr>
+        <p:style>
+          <a:lnRef idx="2">
+            <a:schemeClr val="accent1"/>
+          </a:lnRef>
+          <a:fillRef idx="0">
+            <a:schemeClr val="accent1"/>
+          </a:fillRef>
+          <a:effectRef idx="1">
+            <a:schemeClr val="accent1"/>
+          </a:effectRef>
+          <a:fontRef idx="minor">
+            <a:schemeClr val="tx1"/>
+          </a:fontRef>
+        </p:style>
+      </p:cxnSp>
+      <p:cxnSp>
+        <p:nvCxnSpPr>
+          <p:cNvPr id="19" name="network-edge"/>
+          <p:cNvCxnSpPr/>
+          <p:nvPr/>
+        </p:nvCxnSpPr>
+        <p:spPr>
+          <a:xfrm>
+            <a:off x="8101583" y="1849374"/>
+            <a:ext cx="219457" cy="713232"/>
+          </a:xfrm>
+          <a:prstGeom prst="line">
+            <a:avLst/>
+          </a:prstGeom>
+          <a:ln w="15875">
+            <a:solidFill>
+              <a:srgbClr val="1B4A82"/>
+            </a:solidFill>
+          </a:ln>
+        </p:spPr>
+        <p:style>
+          <a:lnRef idx="2">
+            <a:schemeClr val="accent1"/>
+          </a:lnRef>
+          <a:fillRef idx="0">
+            <a:schemeClr val="accent1"/>
+          </a:fillRef>
+          <a:effectRef idx="1">
+            <a:schemeClr val="accent1"/>
+          </a:effectRef>
+          <a:fontRef idx="minor">
+            <a:schemeClr val="tx1"/>
+          </a:fontRef>
+        </p:style>
+      </p:cxnSp>
+      <p:sp>
+        <p:nvSpPr>
+          <p:cNvPr id="20" name="network-node"/>
+          <p:cNvSpPr/>
+          <p:nvPr/>
+        </p:nvSpPr>
+        <p:spPr>
+          <a:xfrm>
+            <a:off x="8010144" y="1757934"/>
+            <a:ext cx="182880" cy="182880"/>
+          </a:xfrm>
+          <a:prstGeom prst="ellipse">
+            <a:avLst/>
+          </a:prstGeom>
+          <a:solidFill>
+            <a:srgbClr val="2D7FD3"/>
+          </a:solidFill>
+          <a:ln>
+            <a:noFill/>
+          </a:ln>
+          <a:effectLst/>
+        </p:spPr>
+        <p:style>
+          <a:lnRef idx="1">
+            <a:schemeClr val="accent1"/>
+          </a:lnRef>
+          <a:fillRef idx="3">
+            <a:schemeClr val="accent1"/>
+          </a:fillRef>
+          <a:effectRef idx="2">
+            <a:schemeClr val="accent1"/>
+          </a:effectRef>
+          <a:fontRef idx="minor">
+            <a:schemeClr val="lt1"/>
+          </a:fontRef>
+        </p:style>
+        <p:txBody>
+          <a:bodyPr rtlCol="0" anchor="ctr"/>
+          <a:lstStyle/>
+          <a:p>
+            <a:pPr algn="ctr"/>
+          </a:p>
+        </p:txBody>
+      </p:sp>
+      <p:sp>
+        <p:nvSpPr>
+          <p:cNvPr id="21" name="network-node"/>
+          <p:cNvSpPr/>
+          <p:nvPr/>
+        </p:nvSpPr>
+        <p:spPr>
+          <a:xfrm>
+            <a:off x="8549640" y="1125626"/>
+            <a:ext cx="128016" cy="128016"/>
+          </a:xfrm>
+          <a:prstGeom prst="ellipse">
+            <a:avLst/>
+          </a:prstGeom>
+          <a:solidFill>
+            <a:srgbClr val="2D7FD3"/>
+          </a:solidFill>
+          <a:ln>
+            <a:noFill/>
+          </a:ln>
+          <a:effectLst/>
+        </p:spPr>
+        <p:style>
+          <a:lnRef idx="1">
+            <a:schemeClr val="accent1"/>
+          </a:lnRef>
+          <a:fillRef idx="3">
+            <a:schemeClr val="accent1"/>
+          </a:fillRef>
+          <a:effectRef idx="2">
+            <a:schemeClr val="accent1"/>
+          </a:effectRef>
+          <a:fontRef idx="minor">
+            <a:schemeClr val="lt1"/>
+          </a:fontRef>
+        </p:style>
+        <p:txBody>
+          <a:bodyPr rtlCol="0" anchor="ctr"/>
+          <a:lstStyle/>
+          <a:p>
+            <a:pPr algn="ctr"/>
+          </a:p>
+        </p:txBody>
+      </p:sp>
+      <p:sp>
+        <p:nvSpPr>
+          <p:cNvPr id="22" name="network-node"/>
+          <p:cNvSpPr/>
+          <p:nvPr/>
+        </p:nvSpPr>
+        <p:spPr>
+          <a:xfrm>
+            <a:off x="8878824" y="2195474"/>
+            <a:ext cx="128016" cy="128016"/>
+          </a:xfrm>
+          <a:prstGeom prst="ellipse">
+            <a:avLst/>
+          </a:prstGeom>
+          <a:solidFill>
+            <a:srgbClr val="2D7FD3"/>
+          </a:solidFill>
+          <a:ln>
+            <a:noFill/>
+          </a:ln>
+          <a:effectLst/>
+        </p:spPr>
+        <p:style>
+          <a:lnRef idx="1">
+            <a:schemeClr val="accent1"/>
+          </a:lnRef>
+          <a:fillRef idx="3">
+            <a:schemeClr val="accent1"/>
+          </a:fillRef>
+          <a:effectRef idx="2">
+            <a:schemeClr val="accent1"/>
+          </a:effectRef>
+          <a:fontRef idx="minor">
+            <a:schemeClr val="lt1"/>
+          </a:fontRef>
+        </p:style>
+        <p:txBody>
+          <a:bodyPr rtlCol="0" anchor="ctr"/>
+          <a:lstStyle/>
+          <a:p>
+            <a:pPr algn="ctr"/>
+          </a:p>
+        </p:txBody>
+      </p:sp>
+      <p:sp>
+        <p:nvSpPr>
+          <p:cNvPr id="23" name="network-node"/>
+          <p:cNvSpPr/>
+          <p:nvPr/>
+        </p:nvSpPr>
+        <p:spPr>
+          <a:xfrm>
+            <a:off x="9473184" y="1526133"/>
+            <a:ext cx="182880" cy="182880"/>
+          </a:xfrm>
+          <a:prstGeom prst="ellipse">
+            <a:avLst/>
+          </a:prstGeom>
+          <a:solidFill>
+            <a:srgbClr val="2D7FD3"/>
+          </a:solidFill>
+          <a:ln>
+            <a:noFill/>
+          </a:ln>
+          <a:effectLst/>
+        </p:spPr>
+        <p:style>
+          <a:lnRef idx="1">
+            <a:schemeClr val="accent1"/>
+          </a:lnRef>
+          <a:fillRef idx="3">
+            <a:schemeClr val="accent1"/>
+          </a:fillRef>
+          <a:effectRef idx="2">
+            <a:schemeClr val="accent1"/>
+          </a:effectRef>
+          <a:fontRef idx="minor">
+            <a:schemeClr val="lt1"/>
+          </a:fontRef>
+        </p:style>
+        <p:txBody>
+          <a:bodyPr rtlCol="0" anchor="ctr"/>
+          <a:lstStyle/>
+          <a:p>
+            <a:pPr algn="ctr"/>
+          </a:p>
+        </p:txBody>
+      </p:sp>
+      <p:sp>
+        <p:nvSpPr>
+          <p:cNvPr id="24" name="network-node"/>
+          <p:cNvSpPr/>
+          <p:nvPr/>
+        </p:nvSpPr>
+        <p:spPr>
+          <a:xfrm>
+            <a:off x="9902951" y="2409444"/>
+            <a:ext cx="128016" cy="128016"/>
+          </a:xfrm>
+          <a:prstGeom prst="ellipse">
+            <a:avLst/>
+          </a:prstGeom>
+          <a:solidFill>
+            <a:srgbClr val="2D7FD3"/>
+          </a:solidFill>
+          <a:ln>
+            <a:noFill/>
+          </a:ln>
+          <a:effectLst/>
+        </p:spPr>
+        <p:style>
+          <a:lnRef idx="1">
+            <a:schemeClr val="accent1"/>
+          </a:lnRef>
+          <a:fillRef idx="3">
+            <a:schemeClr val="accent1"/>
+          </a:fillRef>
+          <a:effectRef idx="2">
+            <a:schemeClr val="accent1"/>
+          </a:effectRef>
+          <a:fontRef idx="minor">
+            <a:schemeClr val="lt1"/>
+          </a:fontRef>
+        </p:style>
+        <p:txBody>
+          <a:bodyPr rtlCol="0" anchor="ctr"/>
+          <a:lstStyle/>
+          <a:p>
+            <a:pPr algn="ctr"/>
+          </a:p>
+        </p:txBody>
+      </p:sp>
+      <p:sp>
+        <p:nvSpPr>
+          <p:cNvPr id="25" name="network-node"/>
+          <p:cNvSpPr/>
+          <p:nvPr/>
+        </p:nvSpPr>
+        <p:spPr>
+          <a:xfrm>
+            <a:off x="10085832" y="1018641"/>
+            <a:ext cx="128016" cy="128016"/>
+          </a:xfrm>
+          <a:prstGeom prst="ellipse">
+            <a:avLst/>
+          </a:prstGeom>
+          <a:solidFill>
+            <a:srgbClr val="2D7FD3"/>
+          </a:solidFill>
+          <a:ln>
+            <a:noFill/>
+          </a:ln>
+          <a:effectLst/>
+        </p:spPr>
+        <p:style>
+          <a:lnRef idx="1">
+            <a:schemeClr val="accent1"/>
+          </a:lnRef>
+          <a:fillRef idx="3">
+            <a:schemeClr val="accent1"/>
+          </a:fillRef>
+          <a:effectRef idx="2">
+            <a:schemeClr val="accent1"/>
+          </a:effectRef>
+          <a:fontRef idx="minor">
+            <a:schemeClr val="lt1"/>
+          </a:fontRef>
+        </p:style>
+        <p:txBody>
+          <a:bodyPr rtlCol="0" anchor="ctr"/>
+          <a:lstStyle/>
+          <a:p>
+            <a:pPr algn="ctr"/>
+          </a:p>
+        </p:txBody>
+      </p:sp>
+      <p:sp>
+        <p:nvSpPr>
+          <p:cNvPr id="26" name="anomaly-ring"/>
+          <p:cNvSpPr/>
+          <p:nvPr/>
+        </p:nvSpPr>
+        <p:spPr>
+          <a:xfrm>
+            <a:off x="10460735" y="1575054"/>
+            <a:ext cx="548640" cy="548640"/>
+          </a:xfrm>
+          <a:prstGeom prst="ellipse">
+            <a:avLst/>
+          </a:prstGeom>
+          <a:noFill/>
+          <a:ln w="19050">
+            <a:solidFill>
+              <a:srgbClr val="F2A900"/>
+            </a:solidFill>
+          </a:ln>
+          <a:effectLst/>
+        </p:spPr>
+        <p:style>
+          <a:lnRef idx="1">
+            <a:schemeClr val="accent1"/>
+          </a:lnRef>
+          <a:fillRef idx="3">
+            <a:schemeClr val="accent1"/>
+          </a:fillRef>
+          <a:effectRef idx="2">
+            <a:schemeClr val="accent1"/>
+          </a:effectRef>
+          <a:fontRef idx="minor">
+            <a:schemeClr val="lt1"/>
+          </a:fontRef>
+        </p:style>
+        <p:txBody>
+          <a:bodyPr rtlCol="0" anchor="ctr"/>
+          <a:lstStyle/>
+          <a:p>
+            <a:pPr algn="ctr"/>
+          </a:p>
+        </p:txBody>
+      </p:sp>
+      <p:sp>
+        <p:nvSpPr>
+          <p:cNvPr id="27" name="anomaly-node"/>
+          <p:cNvSpPr/>
+          <p:nvPr/>
+        </p:nvSpPr>
+        <p:spPr>
+          <a:xfrm>
+            <a:off x="10616183" y="1730502"/>
+            <a:ext cx="237744" cy="237744"/>
+          </a:xfrm>
+          <a:prstGeom prst="ellipse">
+            <a:avLst/>
+          </a:prstGeom>
+          <a:solidFill>
+            <a:srgbClr val="F2A900"/>
+          </a:solidFill>
+          <a:ln>
+            <a:noFill/>
+          </a:ln>
+          <a:effectLst/>
+        </p:spPr>
+        <p:style>
+          <a:lnRef idx="1">
+            <a:schemeClr val="accent1"/>
+          </a:lnRef>
+          <a:fillRef idx="3">
+            <a:schemeClr val="accent1"/>
+          </a:fillRef>
+          <a:effectRef idx="2">
+            <a:schemeClr val="accent1"/>
+          </a:effectRef>
+          <a:fontRef idx="minor">
+            <a:schemeClr val="lt1"/>
+          </a:fontRef>
+        </p:style>
+        <p:txBody>
+          <a:bodyPr rtlCol="0" anchor="ctr"/>
+          <a:lstStyle/>
+          <a:p>
+            <a:pPr algn="ctr"/>
+          </a:p>
+        </p:txBody>
+      </p:sp>
+      <p:sp>
+        <p:nvSpPr>
+          <p:cNvPr id="28" name="network-node"/>
+          <p:cNvSpPr/>
+          <p:nvPr/>
+        </p:nvSpPr>
+        <p:spPr>
+          <a:xfrm>
+            <a:off x="11183111" y="1196949"/>
+            <a:ext cx="128016" cy="128016"/>
+          </a:xfrm>
+          <a:prstGeom prst="ellipse">
+            <a:avLst/>
+          </a:prstGeom>
+          <a:solidFill>
+            <a:srgbClr val="2D7FD3"/>
+          </a:solidFill>
+          <a:ln>
+            <a:noFill/>
+          </a:ln>
+          <a:effectLst/>
+        </p:spPr>
+        <p:style>
+          <a:lnRef idx="1">
+            <a:schemeClr val="accent1"/>
+          </a:lnRef>
+          <a:fillRef idx="3">
+            <a:schemeClr val="accent1"/>
+          </a:fillRef>
+          <a:effectRef idx="2">
+            <a:schemeClr val="accent1"/>
+          </a:effectRef>
+          <a:fontRef idx="minor">
+            <a:schemeClr val="lt1"/>
+          </a:fontRef>
+        </p:style>
+        <p:txBody>
+          <a:bodyPr rtlCol="0" anchor="ctr"/>
+          <a:lstStyle/>
+          <a:p>
+            <a:pPr algn="ctr"/>
+          </a:p>
+        </p:txBody>
+      </p:sp>
+      <p:sp>
+        <p:nvSpPr>
+          <p:cNvPr id="29" name="network-node"/>
+          <p:cNvSpPr/>
+          <p:nvPr/>
+        </p:nvSpPr>
+        <p:spPr>
+          <a:xfrm>
+            <a:off x="11329415" y="2231136"/>
+            <a:ext cx="128016" cy="128016"/>
+          </a:xfrm>
+          <a:prstGeom prst="ellipse">
+            <a:avLst/>
+          </a:prstGeom>
+          <a:solidFill>
+            <a:srgbClr val="2D7FD3"/>
+          </a:solidFill>
+          <a:ln>
+            <a:noFill/>
+          </a:ln>
+          <a:effectLst/>
+        </p:spPr>
+        <p:style>
+          <a:lnRef idx="1">
+            <a:schemeClr val="accent1"/>
+          </a:lnRef>
+          <a:fillRef idx="3">
+            <a:schemeClr val="accent1"/>
+          </a:fillRef>
+          <a:effectRef idx="2">
+            <a:schemeClr val="accent1"/>
+          </a:effectRef>
+          <a:fontRef idx="minor">
+            <a:schemeClr val="lt1"/>
+          </a:fontRef>
+        </p:style>
+        <p:txBody>
+          <a:bodyPr rtlCol="0" anchor="ctr"/>
+          <a:lstStyle/>
+          <a:p>
+            <a:pPr algn="ctr"/>
+          </a:p>
+        </p:txBody>
+      </p:sp>
+      <p:sp>
+        <p:nvSpPr>
+          <p:cNvPr id="30" name="network-node"/>
+          <p:cNvSpPr/>
+          <p:nvPr/>
+        </p:nvSpPr>
+        <p:spPr>
+          <a:xfrm>
+            <a:off x="8257031" y="2498598"/>
+            <a:ext cx="128016" cy="128016"/>
+          </a:xfrm>
+          <a:prstGeom prst="ellipse">
+            <a:avLst/>
+          </a:prstGeom>
+          <a:solidFill>
+            <a:srgbClr val="2D7FD3"/>
+          </a:solidFill>
+          <a:ln>
+            <a:noFill/>
+          </a:ln>
+          <a:effectLst/>
+        </p:spPr>
+        <p:style>
+          <a:lnRef idx="1">
+            <a:schemeClr val="accent1"/>
+          </a:lnRef>
+          <a:fillRef idx="3">
+            <a:schemeClr val="accent1"/>
+          </a:fillRef>
+          <a:effectRef idx="2">
+            <a:schemeClr val="accent1"/>
+          </a:effectRef>
+          <a:fontRef idx="minor">
+            <a:schemeClr val="lt1"/>
+          </a:fontRef>
+        </p:style>
+        <p:txBody>
+          <a:bodyPr rtlCol="0" anchor="ctr"/>
+          <a:lstStyle/>
+          <a:p>
+            <a:pPr algn="ctr"/>
+          </a:p>
+        </p:txBody>
+      </p:sp>
+      <p:sp>
+        <p:nvSpPr>
+          <p:cNvPr id="31" name="TextBox 30"/>
           <p:cNvSpPr txBox="1"/>
           <p:nvPr/>
         </p:nvSpPr>
         <p:spPr>
           <a:xfrm>
-            <a:off x="548640" y="1188720"/>
-            <a:ext cx="7315200" cy="274320"/>
+            <a:off x="10232135" y="2160270"/>
+            <a:ext cx="1280160" cy="228600"/>
           </a:xfrm>
           <a:prstGeom prst="rect">
             <a:avLst/>
@@ -3581,33 +4510,33 @@
           </a:bodyPr>
           <a:lstStyle/>
           <a:p>
-            <a:pPr algn="l"/>
-            <a:r>
-              <a:rPr sz="1200" b="1" i="0" spc="150">
+            <a:pPr algn="ctr"/>
+            <a:r>
+              <a:rPr sz="1000" b="0" i="0">
                 <a:solidFill>
                   <a:srgbClr val="F2A900"/>
                 </a:solidFill>
                 <a:latin typeface="Calibri"/>
               </a:rPr>
-              <a:t>01  ·  THE PROBLEM  ·  WHY IT MATTERS</a:t>
-            </a:r>
-          </a:p>
-        </p:txBody>
-      </p:sp>
-      <p:sp>
-        <p:nvSpPr>
-          <p:cNvPr id="8" name="paper-card"/>
+              <a:t>unusual traffic</a:t>
+            </a:r>
+          </a:p>
+        </p:txBody>
+      </p:sp>
+      <p:sp>
+        <p:nvSpPr>
+          <p:cNvPr id="32" name="field-problem-title"/>
           <p:cNvSpPr/>
           <p:nvPr/>
         </p:nvSpPr>
         <p:spPr>
           <a:xfrm>
-            <a:off x="548640" y="3200400"/>
-            <a:ext cx="5486400" cy="1417320"/>
+            <a:off x="548640" y="2788920"/>
+            <a:ext cx="11091672" cy="621792"/>
           </a:xfrm>
           <a:prstGeom prst="roundRect">
             <a:avLst>
-              <a:gd name="adj" fmla="val 6000"/>
+              <a:gd name="adj" fmla="val 10000"/>
             </a:avLst>
           </a:prstGeom>
           <a:solidFill>
@@ -3642,281 +4571,14 @@
       </p:sp>
       <p:sp>
         <p:nvSpPr>
-          <p:cNvPr id="9" name="TextBox 8"/>
+          <p:cNvPr id="33" name="TextBox 32"/>
           <p:cNvSpPr txBox="1"/>
           <p:nvPr/>
         </p:nvSpPr>
         <p:spPr>
           <a:xfrm>
-            <a:off x="777240" y="3310128"/>
-            <a:ext cx="3657600" cy="228600"/>
-          </a:xfrm>
-          <a:prstGeom prst="rect">
-            <a:avLst/>
-          </a:prstGeom>
-          <a:noFill/>
-        </p:spPr>
-        <p:txBody>
-          <a:bodyPr wrap="square" lIns="0" tIns="0" rIns="0" bIns="0" anchor="t">
-            <a:spAutoFit/>
-          </a:bodyPr>
-          <a:lstStyle/>
-          <a:p>
-            <a:pPr algn="l"/>
-            <a:r>
-              <a:rPr sz="1100" b="1" i="0" spc="120">
-                <a:solidFill>
-                  <a:srgbClr val="F2A900"/>
-                </a:solidFill>
-                <a:latin typeface="Calibri"/>
-              </a:rPr>
-              <a:t>PAPER UNDER REVIEW</a:t>
-            </a:r>
-          </a:p>
-        </p:txBody>
-      </p:sp>
-      <p:sp>
-        <p:nvSpPr>
-          <p:cNvPr id="10" name="TextBox 9"/>
-          <p:cNvSpPr txBox="1"/>
-          <p:nvPr/>
-        </p:nvSpPr>
-        <p:spPr>
-          <a:xfrm>
-            <a:off x="777240" y="3566160"/>
-            <a:ext cx="4937760" cy="502920"/>
-          </a:xfrm>
-          <a:prstGeom prst="rect">
-            <a:avLst/>
-          </a:prstGeom>
-          <a:noFill/>
-        </p:spPr>
-        <p:txBody>
-          <a:bodyPr wrap="square" lIns="0" tIns="0" rIns="0" bIns="0" anchor="t">
-            <a:spAutoFit/>
-          </a:bodyPr>
-          <a:lstStyle/>
-          <a:p>
-            <a:pPr algn="l"/>
-            <a:r>
-              <a:rPr sz="1400" b="1" i="0">
-                <a:solidFill>
-                  <a:srgbClr val="FFFFFF"/>
-                </a:solidFill>
-                <a:latin typeface="Calibri"/>
-              </a:rPr>
-              <a:t>Anomaly Detection in Network Traffic Using Advanced Machine Learning Techniques</a:t>
-            </a:r>
-          </a:p>
-        </p:txBody>
-      </p:sp>
-      <p:sp>
-        <p:nvSpPr>
-          <p:cNvPr id="11" name="TextBox 10"/>
-          <p:cNvSpPr txBox="1"/>
-          <p:nvPr/>
-        </p:nvSpPr>
-        <p:spPr>
-          <a:xfrm>
-            <a:off x="777240" y="4114800"/>
-            <a:ext cx="5029200" cy="228600"/>
-          </a:xfrm>
-          <a:prstGeom prst="rect">
-            <a:avLst/>
-          </a:prstGeom>
-          <a:noFill/>
-        </p:spPr>
-        <p:txBody>
-          <a:bodyPr wrap="square" lIns="0" tIns="0" rIns="0" bIns="0" anchor="t">
-            <a:spAutoFit/>
-          </a:bodyPr>
-          <a:lstStyle/>
-          <a:p>
-            <a:pPr algn="l"/>
-            <a:r>
-              <a:rPr sz="1200" b="0" i="0">
-                <a:solidFill>
-                  <a:srgbClr val="9FB3CC"/>
-                </a:solidFill>
-                <a:latin typeface="Calibri"/>
-              </a:rPr>
-              <a:t>S. Ness et al.  ·  IEEE Access, vol. 13, pp. 16133–16149, 2025</a:t>
-            </a:r>
-          </a:p>
-        </p:txBody>
-      </p:sp>
-      <p:sp>
-        <p:nvSpPr>
-          <p:cNvPr id="12" name="TextBox 11"/>
-          <p:cNvSpPr txBox="1"/>
-          <p:nvPr/>
-        </p:nvSpPr>
-        <p:spPr>
-          <a:xfrm>
-            <a:off x="777240" y="4361688"/>
-            <a:ext cx="4572000" cy="228600"/>
-          </a:xfrm>
-          <a:prstGeom prst="rect">
-            <a:avLst/>
-          </a:prstGeom>
-          <a:noFill/>
-        </p:spPr>
-        <p:txBody>
-          <a:bodyPr wrap="square" lIns="0" tIns="0" rIns="0" bIns="0" anchor="t">
-            <a:spAutoFit/>
-          </a:bodyPr>
-          <a:lstStyle/>
-          <a:p>
-            <a:pPr algn="l"/>
-            <a:r>
-              <a:rPr sz="1200" b="1" i="0">
-                <a:solidFill>
-                  <a:srgbClr val="FFFFFF"/>
-                </a:solidFill>
-                <a:latin typeface="Calibri"/>
-              </a:rPr>
-              <a:t>Paper number (DOI)  10.1109/ACCESS.2025.3526988</a:t>
-            </a:r>
-          </a:p>
-        </p:txBody>
-      </p:sp>
-      <p:sp>
-        <p:nvSpPr>
-          <p:cNvPr id="13" name="ref-1">
-            <a:hlinkClick r:id="rId3"/>
-          </p:cNvPr>
-          <p:cNvSpPr/>
-          <p:nvPr/>
-        </p:nvSpPr>
-        <p:spPr>
-          <a:xfrm>
-            <a:off x="5532120" y="3310128"/>
-            <a:ext cx="402336" cy="256032"/>
-          </a:xfrm>
-          <a:prstGeom prst="roundRect">
-            <a:avLst>
-              <a:gd name="adj" fmla="val 50000"/>
-            </a:avLst>
-          </a:prstGeom>
-          <a:solidFill>
-            <a:srgbClr val="FFFFFF"/>
-          </a:solidFill>
-          <a:ln w="9525">
-            <a:solidFill>
-              <a:srgbClr val="0B5CAD"/>
-            </a:solidFill>
-          </a:ln>
-          <a:effectLst/>
-        </p:spPr>
-        <p:style>
-          <a:lnRef idx="1">
-            <a:schemeClr val="accent1"/>
-          </a:lnRef>
-          <a:fillRef idx="3">
-            <a:schemeClr val="accent1"/>
-          </a:fillRef>
-          <a:effectRef idx="2">
-            <a:schemeClr val="accent1"/>
-          </a:effectRef>
-          <a:fontRef idx="minor">
-            <a:schemeClr val="lt1"/>
-          </a:fontRef>
-        </p:style>
-        <p:txBody>
-          <a:bodyPr rtlCol="0" anchor="ctr" wrap="square" lIns="0" tIns="0" rIns="0" bIns="0"/>
-          <a:lstStyle/>
-          <a:p>
-            <a:pPr algn="ctr"/>
-            <a:r>
-              <a:rPr sz="1100" b="1" i="0">
-                <a:solidFill>
-                  <a:srgbClr val="0B5CAD"/>
-                </a:solidFill>
-                <a:latin typeface="Calibri"/>
-              </a:rPr>
-              <a:t>[1]</a:t>
-            </a:r>
-          </a:p>
-        </p:txBody>
-      </p:sp>
-      <p:sp>
-        <p:nvSpPr>
-          <p:cNvPr id="14" name="icon-bg-warning"/>
-          <p:cNvSpPr/>
-          <p:nvPr/>
-        </p:nvSpPr>
-        <p:spPr>
-          <a:xfrm>
-            <a:off x="548640" y="4754880"/>
-            <a:ext cx="420624" cy="420624"/>
-          </a:xfrm>
-          <a:prstGeom prst="ellipse">
-            <a:avLst/>
-          </a:prstGeom>
-          <a:solidFill>
-            <a:srgbClr val="2D7FD3"/>
-          </a:solidFill>
-          <a:ln>
-            <a:noFill/>
-          </a:ln>
-          <a:effectLst/>
-        </p:spPr>
-        <p:style>
-          <a:lnRef idx="1">
-            <a:schemeClr val="accent1"/>
-          </a:lnRef>
-          <a:fillRef idx="3">
-            <a:schemeClr val="accent1"/>
-          </a:fillRef>
-          <a:effectRef idx="2">
-            <a:schemeClr val="accent1"/>
-          </a:effectRef>
-          <a:fontRef idx="minor">
-            <a:schemeClr val="lt1"/>
-          </a:fontRef>
-        </p:style>
-        <p:txBody>
-          <a:bodyPr rtlCol="0" anchor="ctr"/>
-          <a:lstStyle/>
-          <a:p>
-            <a:pPr algn="ctr"/>
-          </a:p>
-        </p:txBody>
-      </p:sp>
-      <p:pic>
-        <p:nvPicPr>
-          <p:cNvPr id="15" name="icon-warning" descr="warning icon"/>
-          <p:cNvPicPr>
-            <a:picLocks noChangeAspect="1"/>
-          </p:cNvPicPr>
-          <p:nvPr/>
-        </p:nvPicPr>
-        <p:blipFill>
-          <a:blip r:embed="rId4"/>
-          <a:stretch>
-            <a:fillRect/>
-          </a:stretch>
-        </p:blipFill>
-        <p:spPr>
-          <a:xfrm>
-            <a:off x="636971" y="4843211"/>
-            <a:ext cx="243961" cy="243961"/>
-          </a:xfrm>
-          <a:prstGeom prst="rect">
-            <a:avLst/>
-          </a:prstGeom>
-        </p:spPr>
-      </p:pic>
-      <p:sp>
-        <p:nvSpPr>
-          <p:cNvPr id="16" name="TextBox 15"/>
-          <p:cNvSpPr txBox="1"/>
-          <p:nvPr/>
-        </p:nvSpPr>
-        <p:spPr>
-          <a:xfrm>
-            <a:off x="1097280" y="4681728"/>
-            <a:ext cx="4937760" cy="566928"/>
+            <a:off x="822960" y="2788920"/>
+            <a:ext cx="2011680" cy="621792"/>
           </a:xfrm>
           <a:prstGeom prst="rect">
             <a:avLst/>
@@ -3931,27 +4593,27 @@
           <a:p>
             <a:pPr algn="l"/>
             <a:r>
-              <a:rPr sz="1400" b="0" i="0">
-                <a:solidFill>
-                  <a:srgbClr val="FFFFFF"/>
-                </a:solidFill>
-                <a:latin typeface="Calibri"/>
-              </a:rPr>
-              <a:t>A missed attack costs money. A false alarm wastes analysts' time.</a:t>
-            </a:r>
-          </a:p>
-        </p:txBody>
-      </p:sp>
-      <p:sp>
-        <p:nvSpPr>
-          <p:cNvPr id="17" name="TextBox 16"/>
+              <a:rPr sz="1100" b="1" i="0" spc="120">
+                <a:solidFill>
+                  <a:srgbClr val="F2A900"/>
+                </a:solidFill>
+                <a:latin typeface="Calibri"/>
+              </a:rPr>
+              <a:t>PROBLEM TITLE</a:t>
+            </a:r>
+          </a:p>
+        </p:txBody>
+      </p:sp>
+      <p:sp>
+        <p:nvSpPr>
+          <p:cNvPr id="34" name="TextBox 33"/>
           <p:cNvSpPr txBox="1"/>
           <p:nvPr/>
         </p:nvSpPr>
         <p:spPr>
           <a:xfrm>
-            <a:off x="6309360" y="1188720"/>
-            <a:ext cx="5303520" cy="274320"/>
+            <a:off x="2926080" y="2788920"/>
+            <a:ext cx="8503920" cy="621792"/>
           </a:xfrm>
           <a:prstGeom prst="rect">
             <a:avLst/>
@@ -3959,38 +4621,38 @@
           <a:noFill/>
         </p:spPr>
         <p:txBody>
-          <a:bodyPr wrap="square" lIns="0" tIns="0" rIns="0" bIns="0" anchor="t">
+          <a:bodyPr wrap="square" lIns="0" tIns="0" rIns="0" bIns="0" anchor="ctr">
             <a:spAutoFit/>
           </a:bodyPr>
           <a:lstStyle/>
           <a:p>
             <a:pPr algn="l"/>
             <a:r>
-              <a:rPr sz="1200" b="1" i="0" spc="120">
-                <a:solidFill>
-                  <a:srgbClr val="F2A900"/>
-                </a:solidFill>
-                <a:latin typeface="Calibri"/>
-              </a:rPr>
-              <a:t>INDUSTRY LOSS  ·  WHAT FAILED DEFENCE COSTS</a:t>
-            </a:r>
-          </a:p>
-        </p:txBody>
-      </p:sp>
-      <p:sp>
-        <p:nvSpPr>
-          <p:cNvPr id="18" name="Rounded Rectangle 17"/>
+              <a:rPr sz="1700" b="1" i="0">
+                <a:solidFill>
+                  <a:srgbClr val="FFFFFF"/>
+                </a:solidFill>
+                <a:latin typeface="Calibri"/>
+              </a:rPr>
+              <a:t>Testing and Improving ML-Based Network Attack Detection</a:t>
+            </a:r>
+          </a:p>
+        </p:txBody>
+      </p:sp>
+      <p:sp>
+        <p:nvSpPr>
+          <p:cNvPr id="35" name="field-ieee-paper"/>
           <p:cNvSpPr/>
           <p:nvPr/>
         </p:nvSpPr>
         <p:spPr>
           <a:xfrm>
-            <a:off x="6309360" y="1600200"/>
-            <a:ext cx="5330952" cy="1097280"/>
+            <a:off x="548640" y="3483864"/>
+            <a:ext cx="11091672" cy="868680"/>
           </a:xfrm>
           <a:prstGeom prst="roundRect">
             <a:avLst>
-              <a:gd name="adj" fmla="val 8000"/>
+              <a:gd name="adj" fmla="val 10000"/>
             </a:avLst>
           </a:prstGeom>
           <a:solidFill>
@@ -4025,14 +4687,14 @@
       </p:sp>
       <p:sp>
         <p:nvSpPr>
-          <p:cNvPr id="19" name="TextBox 18"/>
+          <p:cNvPr id="36" name="TextBox 35"/>
           <p:cNvSpPr txBox="1"/>
           <p:nvPr/>
         </p:nvSpPr>
         <p:spPr>
           <a:xfrm>
-            <a:off x="6537960" y="1600200"/>
-            <a:ext cx="2103120" cy="1097280"/>
+            <a:off x="822960" y="3483864"/>
+            <a:ext cx="2011680" cy="868680"/>
           </a:xfrm>
           <a:prstGeom prst="rect">
             <a:avLst/>
@@ -4047,27 +4709,27 @@
           <a:p>
             <a:pPr algn="l"/>
             <a:r>
-              <a:rPr sz="3200" b="1" i="0">
+              <a:rPr sz="1100" b="1" i="0" spc="120">
                 <a:solidFill>
                   <a:srgbClr val="F2A900"/>
                 </a:solidFill>
-                <a:latin typeface="Cambria"/>
-              </a:rPr>
-              <a:t>$4.99M</a:t>
-            </a:r>
-          </a:p>
-        </p:txBody>
-      </p:sp>
-      <p:sp>
-        <p:nvSpPr>
-          <p:cNvPr id="20" name="TextBox 19"/>
+                <a:latin typeface="Calibri"/>
+              </a:rPr>
+              <a:t>IEEE PAPER</a:t>
+            </a:r>
+          </a:p>
+        </p:txBody>
+      </p:sp>
+      <p:sp>
+        <p:nvSpPr>
+          <p:cNvPr id="37" name="TextBox 36"/>
           <p:cNvSpPr txBox="1"/>
           <p:nvPr/>
         </p:nvSpPr>
         <p:spPr>
           <a:xfrm>
-            <a:off x="8686800" y="1709928"/>
-            <a:ext cx="2423160" cy="877824"/>
+            <a:off x="2926080" y="3483864"/>
+            <a:ext cx="6675120" cy="868680"/>
           </a:xfrm>
           <a:prstGeom prst="rect">
             <a:avLst/>
@@ -4082,29 +4744,41 @@
           <a:p>
             <a:pPr algn="l"/>
             <a:r>
-              <a:rPr sz="1400" b="0" i="0">
+              <a:rPr sz="1500" b="1" i="0">
                 <a:solidFill>
                   <a:srgbClr val="FFFFFF"/>
                 </a:solidFill>
                 <a:latin typeface="Calibri"/>
               </a:rPr>
-              <a:t>average cost of one data breach worldwide, a record (+12%)</a:t>
-            </a:r>
-          </a:p>
-        </p:txBody>
-      </p:sp>
-      <p:sp>
-        <p:nvSpPr>
-          <p:cNvPr id="21" name="ref-2">
-            <a:hlinkClick r:id="rId5"/>
+              <a:t>Anomaly Detection in Network Traffic Using Advanced Machine Learning Techniques</a:t>
+            </a:r>
+          </a:p>
+          <a:p>
+            <a:pPr algn="l"/>
+            <a:r>
+              <a:rPr sz="1200" b="0" i="0">
+                <a:solidFill>
+                  <a:srgbClr val="9FB3CC"/>
+                </a:solidFill>
+                <a:latin typeface="Calibri"/>
+              </a:rPr>
+              <a:t>S. Ness et al.  ·  IEEE Access, 2025</a:t>
+            </a:r>
+          </a:p>
+        </p:txBody>
+      </p:sp>
+      <p:sp>
+        <p:nvSpPr>
+          <p:cNvPr id="38" name="Rounded Rectangle 37">
+            <a:hlinkClick r:id="rId3"/>
           </p:cNvPr>
           <p:cNvSpPr/>
           <p:nvPr/>
         </p:nvSpPr>
         <p:spPr>
           <a:xfrm>
-            <a:off x="11155680" y="2020824"/>
-            <a:ext cx="402336" cy="256032"/>
+            <a:off x="9829800" y="3735324"/>
+            <a:ext cx="1645920" cy="365760"/>
           </a:xfrm>
           <a:prstGeom prst="roundRect">
             <a:avLst>
@@ -4114,10 +4788,8 @@
           <a:solidFill>
             <a:srgbClr val="FFFFFF"/>
           </a:solidFill>
-          <a:ln w="9525">
-            <a:solidFill>
-              <a:srgbClr val="0B5CAD"/>
-            </a:solidFill>
+          <a:ln>
+            <a:noFill/>
           </a:ln>
           <a:effectLst/>
         </p:spPr>
@@ -4141,31 +4813,31 @@
           <a:p>
             <a:pPr algn="ctr"/>
             <a:r>
-              <a:rPr sz="1100" b="1" i="0">
+              <a:rPr sz="1200" b="1" i="0">
                 <a:solidFill>
                   <a:srgbClr val="0B5CAD"/>
                 </a:solidFill>
                 <a:latin typeface="Calibri"/>
               </a:rPr>
-              <a:t>[2]</a:t>
-            </a:r>
-          </a:p>
-        </p:txBody>
-      </p:sp>
-      <p:sp>
-        <p:nvSpPr>
-          <p:cNvPr id="22" name="Rounded Rectangle 21"/>
+              <a:t>IEEE Xplore ›</a:t>
+            </a:r>
+          </a:p>
+        </p:txBody>
+      </p:sp>
+      <p:sp>
+        <p:nvSpPr>
+          <p:cNvPr id="39" name="field-paper-number"/>
           <p:cNvSpPr/>
           <p:nvPr/>
         </p:nvSpPr>
         <p:spPr>
           <a:xfrm>
-            <a:off x="6309360" y="2834640"/>
-            <a:ext cx="5330952" cy="1097280"/>
+            <a:off x="548640" y="4425696"/>
+            <a:ext cx="11091672" cy="868680"/>
           </a:xfrm>
           <a:prstGeom prst="roundRect">
             <a:avLst>
-              <a:gd name="adj" fmla="val 8000"/>
+              <a:gd name="adj" fmla="val 10000"/>
             </a:avLst>
           </a:prstGeom>
           <a:solidFill>
@@ -4200,14 +4872,14 @@
       </p:sp>
       <p:sp>
         <p:nvSpPr>
-          <p:cNvPr id="23" name="TextBox 22"/>
+          <p:cNvPr id="40" name="TextBox 39"/>
           <p:cNvSpPr txBox="1"/>
           <p:nvPr/>
         </p:nvSpPr>
         <p:spPr>
           <a:xfrm>
-            <a:off x="6537960" y="2834640"/>
-            <a:ext cx="2103120" cy="1097280"/>
+            <a:off x="822960" y="4425696"/>
+            <a:ext cx="2011680" cy="868680"/>
           </a:xfrm>
           <a:prstGeom prst="rect">
             <a:avLst/>
@@ -4222,27 +4894,27 @@
           <a:p>
             <a:pPr algn="l"/>
             <a:r>
-              <a:rPr sz="3200" b="1" i="0">
+              <a:rPr sz="1100" b="1" i="0" spc="120">
                 <a:solidFill>
                   <a:srgbClr val="F2A900"/>
                 </a:solidFill>
-                <a:latin typeface="Cambria"/>
-              </a:rPr>
-              <a:t>247 days</a:t>
-            </a:r>
-          </a:p>
-        </p:txBody>
-      </p:sp>
-      <p:sp>
-        <p:nvSpPr>
-          <p:cNvPr id="24" name="TextBox 23"/>
+                <a:latin typeface="Calibri"/>
+              </a:rPr>
+              <a:t>PAPER NUMBER</a:t>
+            </a:r>
+          </a:p>
+        </p:txBody>
+      </p:sp>
+      <p:sp>
+        <p:nvSpPr>
+          <p:cNvPr id="41" name="TextBox 40"/>
           <p:cNvSpPr txBox="1"/>
           <p:nvPr/>
         </p:nvSpPr>
         <p:spPr>
           <a:xfrm>
-            <a:off x="8686800" y="2944368"/>
-            <a:ext cx="2423160" cy="877824"/>
+            <a:off x="2926080" y="4425696"/>
+            <a:ext cx="6675120" cy="868680"/>
           </a:xfrm>
           <a:prstGeom prst="rect">
             <a:avLst/>
@@ -4257,29 +4929,41 @@
           <a:p>
             <a:pPr algn="l"/>
             <a:r>
-              <a:rPr sz="1400" b="0" i="0">
+              <a:rPr sz="1500" b="1" i="0">
                 <a:solidFill>
                   <a:srgbClr val="FFFFFF"/>
                 </a:solidFill>
                 <a:latin typeface="Calibri"/>
               </a:rPr>
-              <a:t>average time to find and contain a breach</a:t>
-            </a:r>
-          </a:p>
-        </p:txBody>
-      </p:sp>
-      <p:sp>
-        <p:nvSpPr>
-          <p:cNvPr id="25" name="ref-2">
-            <a:hlinkClick r:id="rId5"/>
+              <a:t>IEEE Access, vol. 13, pp. 16133–16149</a:t>
+            </a:r>
+          </a:p>
+          <a:p>
+            <a:pPr algn="l"/>
+            <a:r>
+              <a:rPr sz="1200" b="0" i="0">
+                <a:solidFill>
+                  <a:srgbClr val="9FB3CC"/>
+                </a:solidFill>
+                <a:latin typeface="Calibri"/>
+              </a:rPr>
+              <a:t>IEEE Xplore document 10833631  ·  DOI 10.1109/ACCESS.2025.3526988</a:t>
+            </a:r>
+          </a:p>
+        </p:txBody>
+      </p:sp>
+      <p:sp>
+        <p:nvSpPr>
+          <p:cNvPr id="42" name="Rounded Rectangle 41">
+            <a:hlinkClick r:id="rId4"/>
           </p:cNvPr>
           <p:cNvSpPr/>
           <p:nvPr/>
         </p:nvSpPr>
         <p:spPr>
           <a:xfrm>
-            <a:off x="11155680" y="3255264"/>
-            <a:ext cx="402336" cy="256032"/>
+            <a:off x="9829800" y="4677156"/>
+            <a:ext cx="1645920" cy="365760"/>
           </a:xfrm>
           <a:prstGeom prst="roundRect">
             <a:avLst>
@@ -4289,10 +4973,8 @@
           <a:solidFill>
             <a:srgbClr val="FFFFFF"/>
           </a:solidFill>
-          <a:ln w="9525">
-            <a:solidFill>
-              <a:srgbClr val="0B5CAD"/>
-            </a:solidFill>
+          <a:ln>
+            <a:noFill/>
           </a:ln>
           <a:effectLst/>
         </p:spPr>
@@ -4316,31 +4998,31 @@
           <a:p>
             <a:pPr algn="ctr"/>
             <a:r>
-              <a:rPr sz="1100" b="1" i="0">
+              <a:rPr sz="1200" b="1" i="0">
                 <a:solidFill>
                   <a:srgbClr val="0B5CAD"/>
                 </a:solidFill>
                 <a:latin typeface="Calibri"/>
               </a:rPr>
-              <a:t>[2]</a:t>
-            </a:r>
-          </a:p>
-        </p:txBody>
-      </p:sp>
-      <p:sp>
-        <p:nvSpPr>
-          <p:cNvPr id="26" name="Rounded Rectangle 25"/>
+              <a:t>Open DOI ›</a:t>
+            </a:r>
+          </a:p>
+        </p:txBody>
+      </p:sp>
+      <p:sp>
+        <p:nvSpPr>
+          <p:cNvPr id="43" name="field-team-members"/>
           <p:cNvSpPr/>
           <p:nvPr/>
         </p:nvSpPr>
         <p:spPr>
           <a:xfrm>
-            <a:off x="6309360" y="4069080"/>
-            <a:ext cx="5330952" cy="1097280"/>
+            <a:off x="548640" y="5367528"/>
+            <a:ext cx="11091672" cy="640080"/>
           </a:xfrm>
           <a:prstGeom prst="roundRect">
             <a:avLst>
-              <a:gd name="adj" fmla="val 8000"/>
+              <a:gd name="adj" fmla="val 10000"/>
             </a:avLst>
           </a:prstGeom>
           <a:solidFill>
@@ -4375,14 +5057,14 @@
       </p:sp>
       <p:sp>
         <p:nvSpPr>
-          <p:cNvPr id="27" name="TextBox 26"/>
+          <p:cNvPr id="44" name="TextBox 43"/>
           <p:cNvSpPr txBox="1"/>
           <p:nvPr/>
         </p:nvSpPr>
         <p:spPr>
           <a:xfrm>
-            <a:off x="6537960" y="4069080"/>
-            <a:ext cx="2103120" cy="1097280"/>
+            <a:off x="822960" y="5367528"/>
+            <a:ext cx="2011680" cy="640080"/>
           </a:xfrm>
           <a:prstGeom prst="rect">
             <a:avLst/>
@@ -4397,27 +5079,27 @@
           <a:p>
             <a:pPr algn="l"/>
             <a:r>
-              <a:rPr sz="3200" b="1" i="0">
+              <a:rPr sz="1100" b="1" i="0" spc="120">
                 <a:solidFill>
                   <a:srgbClr val="F2A900"/>
                 </a:solidFill>
-                <a:latin typeface="Cambria"/>
-              </a:rPr>
-              <a:t>$20.9B</a:t>
-            </a:r>
-          </a:p>
-        </p:txBody>
-      </p:sp>
-      <p:sp>
-        <p:nvSpPr>
-          <p:cNvPr id="28" name="TextBox 27"/>
+                <a:latin typeface="Calibri"/>
+              </a:rPr>
+              <a:t>TEAM MEMBERS</a:t>
+            </a:r>
+          </a:p>
+        </p:txBody>
+      </p:sp>
+      <p:sp>
+        <p:nvSpPr>
+          <p:cNvPr id="45" name="TextBox 44"/>
           <p:cNvSpPr txBox="1"/>
           <p:nvPr/>
         </p:nvSpPr>
         <p:spPr>
           <a:xfrm>
-            <a:off x="8686800" y="4178808"/>
-            <a:ext cx="2423160" cy="877824"/>
+            <a:off x="2926080" y="5367528"/>
+            <a:ext cx="8503920" cy="640080"/>
           </a:xfrm>
           <a:prstGeom prst="rect">
             <a:avLst/>
@@ -4432,143 +5114,20 @@
           <a:p>
             <a:pPr algn="l"/>
             <a:r>
-              <a:rPr sz="1400" b="0" i="0">
+              <a:rPr sz="1800" b="1" i="0">
                 <a:solidFill>
                   <a:srgbClr val="FFFFFF"/>
                 </a:solidFill>
                 <a:latin typeface="Calibri"/>
               </a:rPr>
-              <a:t>cybercrime losses reported to the FBI in 2025 (+26%)</a:t>
-            </a:r>
-          </a:p>
-        </p:txBody>
-      </p:sp>
-      <p:sp>
-        <p:nvSpPr>
-          <p:cNvPr id="29" name="ref-3">
-            <a:hlinkClick r:id="rId6"/>
-          </p:cNvPr>
-          <p:cNvSpPr/>
-          <p:nvPr/>
-        </p:nvSpPr>
-        <p:spPr>
-          <a:xfrm>
-            <a:off x="11155680" y="4489704"/>
-            <a:ext cx="402336" cy="256032"/>
-          </a:xfrm>
-          <a:prstGeom prst="roundRect">
-            <a:avLst>
-              <a:gd name="adj" fmla="val 50000"/>
-            </a:avLst>
-          </a:prstGeom>
-          <a:solidFill>
-            <a:srgbClr val="FFFFFF"/>
-          </a:solidFill>
-          <a:ln w="9525">
-            <a:solidFill>
-              <a:srgbClr val="0B5CAD"/>
-            </a:solidFill>
-          </a:ln>
-          <a:effectLst/>
-        </p:spPr>
-        <p:style>
-          <a:lnRef idx="1">
-            <a:schemeClr val="accent1"/>
-          </a:lnRef>
-          <a:fillRef idx="3">
-            <a:schemeClr val="accent1"/>
-          </a:fillRef>
-          <a:effectRef idx="2">
-            <a:schemeClr val="accent1"/>
-          </a:effectRef>
-          <a:fontRef idx="minor">
-            <a:schemeClr val="lt1"/>
-          </a:fontRef>
-        </p:style>
-        <p:txBody>
-          <a:bodyPr rtlCol="0" anchor="ctr" wrap="square" lIns="0" tIns="0" rIns="0" bIns="0"/>
-          <a:lstStyle/>
-          <a:p>
-            <a:pPr algn="ctr"/>
-            <a:r>
-              <a:rPr sz="1100" b="1" i="0">
-                <a:solidFill>
-                  <a:srgbClr val="0B5CAD"/>
-                </a:solidFill>
-                <a:latin typeface="Calibri"/>
-              </a:rPr>
-              <a:t>[3]</a:t>
-            </a:r>
-          </a:p>
-        </p:txBody>
-      </p:sp>
-      <p:sp>
-        <p:nvSpPr>
-          <p:cNvPr id="30" name="question-bar"/>
-          <p:cNvSpPr/>
-          <p:nvPr/>
-        </p:nvSpPr>
-        <p:spPr>
-          <a:xfrm>
-            <a:off x="548640" y="5440680"/>
-            <a:ext cx="11091672" cy="749808"/>
-          </a:xfrm>
-          <a:prstGeom prst="roundRect">
-            <a:avLst>
-              <a:gd name="adj" fmla="val 12000"/>
-            </a:avLst>
-          </a:prstGeom>
-          <a:solidFill>
-            <a:srgbClr val="0B5CAD"/>
-          </a:solidFill>
-          <a:ln>
-            <a:noFill/>
-          </a:ln>
-          <a:effectLst/>
-        </p:spPr>
-        <p:style>
-          <a:lnRef idx="1">
-            <a:schemeClr val="accent1"/>
-          </a:lnRef>
-          <a:fillRef idx="3">
-            <a:schemeClr val="accent1"/>
-          </a:fillRef>
-          <a:effectRef idx="2">
-            <a:schemeClr val="accent1"/>
-          </a:effectRef>
-          <a:fontRef idx="minor">
-            <a:schemeClr val="lt1"/>
-          </a:fontRef>
-        </p:style>
-        <p:txBody>
-          <a:bodyPr rtlCol="0" anchor="ctr" wrap="square" lIns="274320" tIns="0" rIns="182880" bIns="0"/>
-          <a:lstStyle/>
-          <a:p>
-            <a:pPr algn="l"/>
-            <a:r>
-              <a:rPr sz="1800" b="1" i="0">
-                <a:solidFill>
-                  <a:srgbClr val="F2A900"/>
-                </a:solidFill>
-                <a:latin typeface="Calibri"/>
-              </a:rPr>
-              <a:t>Our question   </a:t>
-            </a:r>
-            <a:r>
-              <a:rPr sz="1800" b="0" i="0">
-                <a:solidFill>
-                  <a:srgbClr val="FFFFFF"/>
-                </a:solidFill>
-                <a:latin typeface="Calibri"/>
-              </a:rPr>
-              <a:t>Can we trust a detector's accuracy score, and does it hold on new traffic?</a:t>
-            </a:r>
-          </a:p>
-        </p:txBody>
-      </p:sp>
-      <p:sp>
-        <p:nvSpPr>
-          <p:cNvPr id="31" name="footer"/>
+              <a:t>Mahidhar   ·   Sasikanth   ·   Harshith</a:t>
+            </a:r>
+          </a:p>
+        </p:txBody>
+      </p:sp>
+      <p:sp>
+        <p:nvSpPr>
+          <p:cNvPr id="46" name="footer"/>
           <p:cNvSpPr txBox="1"/>
           <p:nvPr/>
         </p:nvSpPr>
@@ -4603,8 +5162,8 @@
       </p:sp>
       <p:sp>
         <p:nvSpPr>
-          <p:cNvPr id="32" name="nav-1">
-            <a:hlinkClick action="ppaction://hlinksldjump" r:id="rId7"/>
+          <p:cNvPr id="47" name="nav-1">
+            <a:hlinkClick action="ppaction://hlinksldjump" r:id="rId5"/>
           </p:cNvPr>
           <p:cNvSpPr/>
           <p:nvPr/>
@@ -4658,8 +5217,8 @@
       </p:sp>
       <p:sp>
         <p:nvSpPr>
-          <p:cNvPr id="33" name="nav-2">
-            <a:hlinkClick action="ppaction://hlinksldjump" r:id="rId8"/>
+          <p:cNvPr id="48" name="nav-2">
+            <a:hlinkClick action="ppaction://hlinksldjump" r:id="rId6"/>
           </p:cNvPr>
           <p:cNvSpPr/>
           <p:nvPr/>
@@ -4713,8 +5272,8 @@
       </p:sp>
       <p:sp>
         <p:nvSpPr>
-          <p:cNvPr id="34" name="nav-3">
-            <a:hlinkClick action="ppaction://hlinksldjump" r:id="rId9"/>
+          <p:cNvPr id="49" name="nav-3">
+            <a:hlinkClick action="ppaction://hlinksldjump" r:id="rId7"/>
           </p:cNvPr>
           <p:cNvSpPr/>
           <p:nvPr/>
@@ -4768,8 +5327,8 @@
       </p:sp>
       <p:sp>
         <p:nvSpPr>
-          <p:cNvPr id="35" name="nav-4">
-            <a:hlinkClick action="ppaction://hlinksldjump" r:id="rId10"/>
+          <p:cNvPr id="50" name="nav-4">
+            <a:hlinkClick action="ppaction://hlinksldjump" r:id="rId8"/>
           </p:cNvPr>
           <p:cNvSpPr/>
           <p:nvPr/>
@@ -4823,8 +5382,8 @@
       </p:sp>
       <p:sp>
         <p:nvSpPr>
-          <p:cNvPr id="36" name="nav-5">
-            <a:hlinkClick action="ppaction://hlinksldjump" r:id="rId11"/>
+          <p:cNvPr id="51" name="nav-5">
+            <a:hlinkClick action="ppaction://hlinksldjump" r:id="rId9"/>
           </p:cNvPr>
           <p:cNvSpPr/>
           <p:nvPr/>
@@ -4878,8 +5437,8 @@
       </p:sp>
       <p:sp>
         <p:nvSpPr>
-          <p:cNvPr id="37" name="nav-6">
-            <a:hlinkClick action="ppaction://hlinksldjump" r:id="rId12"/>
+          <p:cNvPr id="52" name="nav-6">
+            <a:hlinkClick action="ppaction://hlinksldjump" r:id="rId10"/>
           </p:cNvPr>
           <p:cNvSpPr/>
           <p:nvPr/>
@@ -6629,7 +7188,7 @@
                 </a:solidFill>
                 <a:latin typeface="Cambria"/>
               </a:rPr>
-              <a:t>The Paper's Numbers, and What Is Lost</a:t>
+              <a:t>Can 100% Accuracy Be Trusted?</a:t>
             </a:r>
           </a:p>
         </p:txBody>
@@ -6664,109 +7223,21 @@
                 </a:solidFill>
                 <a:latin typeface="Calibri"/>
               </a:rPr>
-              <a:t>03  ·  PAPER NUMBERS AND LOSSES</a:t>
-            </a:r>
-          </a:p>
-        </p:txBody>
-      </p:sp>
-      <p:sp>
-        <p:nvSpPr>
-          <p:cNvPr id="4" name="TextBox 3"/>
-          <p:cNvSpPr txBox="1"/>
-          <p:nvPr/>
-        </p:nvSpPr>
-        <p:spPr>
-          <a:xfrm>
-            <a:off x="548640" y="1325880"/>
-            <a:ext cx="6949440" cy="274320"/>
-          </a:xfrm>
-          <a:prstGeom prst="rect">
-            <a:avLst/>
-          </a:prstGeom>
-          <a:noFill/>
-        </p:spPr>
-        <p:txBody>
-          <a:bodyPr wrap="square" lIns="0" tIns="0" rIns="0" bIns="0" anchor="t">
-            <a:spAutoFit/>
-          </a:bodyPr>
-          <a:lstStyle/>
-          <a:p>
-            <a:pPr algn="l"/>
-            <a:r>
-              <a:rPr sz="1400" b="1" i="0">
-                <a:solidFill>
-                  <a:srgbClr val="13233A"/>
-                </a:solidFill>
-                <a:latin typeface="Calibri"/>
-              </a:rPr>
-              <a:t>Accuracy on practice (training) vs the exam (test), as reported [1]</a:t>
-            </a:r>
-          </a:p>
-        </p:txBody>
-      </p:sp>
-      <p:graphicFrame>
-        <p:nvGraphicFramePr>
-          <p:cNvPr id="5" name="chart" descr="Training vs test accuracy for 7 models; every model loses 6 to 16 points on the test"/>
-          <p:cNvGraphicFramePr>
-            <a:graphicFrameLocks noGrp="1"/>
-          </p:cNvGraphicFramePr>
-          <p:nvPr/>
-        </p:nvGraphicFramePr>
-        <p:xfrm>
-          <a:off x="548640" y="1645920"/>
-          <a:ext cx="6949440" cy="3246120"/>
-        </p:xfrm>
-        <a:graphic>
-          <a:graphicData uri="http://schemas.openxmlformats.org/drawingml/2006/chart">
-            <c:chart xmlns:c="http://schemas.openxmlformats.org/drawingml/2006/chart" r:id="rId2"/>
-          </a:graphicData>
-        </a:graphic>
-      </p:graphicFrame>
-      <p:sp>
-        <p:nvSpPr>
-          <p:cNvPr id="6" name="TextBox 5"/>
-          <p:cNvSpPr txBox="1"/>
-          <p:nvPr/>
-        </p:nvSpPr>
-        <p:spPr>
-          <a:xfrm>
-            <a:off x="548640" y="4919472"/>
-            <a:ext cx="6949440" cy="457200"/>
-          </a:xfrm>
-          <a:prstGeom prst="rect">
-            <a:avLst/>
-          </a:prstGeom>
-          <a:noFill/>
-        </p:spPr>
-        <p:txBody>
-          <a:bodyPr wrap="square" lIns="0" tIns="0" rIns="0" bIns="0" anchor="t">
-            <a:spAutoFit/>
-          </a:bodyPr>
-          <a:lstStyle/>
-          <a:p>
-            <a:pPr algn="l"/>
-            <a:r>
-              <a:rPr sz="1200" b="0" i="0">
-                <a:solidFill>
-                  <a:srgbClr val="5A6B80"/>
-                </a:solidFill>
-                <a:latin typeface="Calibri"/>
-              </a:rPr>
-              <a:t>*LightGBM: the abstract says 1.00 → 0.85. Tables 5, 6 and 8 print it reversed (test 1.00, training 0.85).</a:t>
-            </a:r>
-          </a:p>
-        </p:txBody>
-      </p:sp>
-      <p:sp>
-        <p:nvSpPr>
-          <p:cNvPr id="7" name="loss-card-1"/>
+              <a:t>03  ·  THE PAPER'S NUMBERS VS THE INDUSTRY'S LOSS</a:t>
+            </a:r>
+          </a:p>
+        </p:txBody>
+      </p:sp>
+      <p:sp>
+        <p:nvSpPr>
+          <p:cNvPr id="4" name="panel-paper"/>
           <p:cNvSpPr/>
           <p:nvPr/>
         </p:nvSpPr>
         <p:spPr>
           <a:xfrm>
-            <a:off x="7818120" y="1371600"/>
-            <a:ext cx="3822191" cy="1261872"/>
+            <a:off x="548640" y="1371600"/>
+            <a:ext cx="6720840" cy="3977639"/>
           </a:xfrm>
           <a:prstGeom prst="roundRect">
             <a:avLst>
@@ -6807,97 +7278,25 @@
       </p:sp>
       <p:sp>
         <p:nvSpPr>
-          <p:cNvPr id="8" name="TextBox 7"/>
-          <p:cNvSpPr txBox="1"/>
-          <p:nvPr/>
-        </p:nvSpPr>
-        <p:spPr>
-          <a:xfrm>
-            <a:off x="8046720" y="1444752"/>
-            <a:ext cx="3474720" cy="502920"/>
-          </a:xfrm>
-          <a:prstGeom prst="rect">
-            <a:avLst/>
-          </a:prstGeom>
-          <a:noFill/>
-        </p:spPr>
-        <p:txBody>
-          <a:bodyPr wrap="square" lIns="0" tIns="0" rIns="0" bIns="0" anchor="ctr">
-            <a:spAutoFit/>
-          </a:bodyPr>
-          <a:lstStyle/>
-          <a:p>
-            <a:pPr algn="l"/>
-            <a:r>
-              <a:rPr sz="2600" b="1" i="0">
-                <a:solidFill>
-                  <a:srgbClr val="0B5CAD"/>
-                </a:solidFill>
-                <a:latin typeface="Cambria"/>
-              </a:rPr>
-              <a:t>6–16 pts</a:t>
-            </a:r>
-          </a:p>
-        </p:txBody>
-      </p:sp>
-      <p:sp>
-        <p:nvSpPr>
-          <p:cNvPr id="9" name="TextBox 8"/>
-          <p:cNvSpPr txBox="1"/>
-          <p:nvPr/>
-        </p:nvSpPr>
-        <p:spPr>
-          <a:xfrm>
-            <a:off x="8046720" y="1965960"/>
-            <a:ext cx="3429000" cy="640080"/>
-          </a:xfrm>
-          <a:prstGeom prst="rect">
-            <a:avLst/>
-          </a:prstGeom>
-          <a:noFill/>
-        </p:spPr>
-        <p:txBody>
-          <a:bodyPr wrap="square" lIns="0" tIns="0" rIns="0" bIns="0" anchor="t">
-            <a:spAutoFit/>
-          </a:bodyPr>
-          <a:lstStyle/>
-          <a:p>
-            <a:pPr algn="l"/>
-            <a:r>
-              <a:rPr sz="1250" b="0" i="0">
-                <a:solidFill>
-                  <a:srgbClr val="13233A"/>
-                </a:solidFill>
-                <a:latin typeface="Calibri"/>
-              </a:rPr>
-              <a:t>lost from practice to exam, in every model</a:t>
-            </a:r>
-          </a:p>
-        </p:txBody>
-      </p:sp>
-      <p:sp>
-        <p:nvSpPr>
-          <p:cNvPr id="10" name="loss-card-2"/>
+          <p:cNvPr id="5" name="Rounded Rectangle 4"/>
           <p:cNvSpPr/>
           <p:nvPr/>
         </p:nvSpPr>
         <p:spPr>
           <a:xfrm>
-            <a:off x="7818120" y="2743200"/>
-            <a:ext cx="3822191" cy="1261872"/>
+            <a:off x="777240" y="1536192"/>
+            <a:ext cx="1280160" cy="274320"/>
           </a:xfrm>
           <a:prstGeom prst="roundRect">
             <a:avLst>
-              <a:gd name="adj" fmla="val 8000"/>
+              <a:gd name="adj" fmla="val 50000"/>
             </a:avLst>
           </a:prstGeom>
           <a:solidFill>
-            <a:srgbClr val="FFFFFF"/>
+            <a:srgbClr val="0B5CAD"/>
           </a:solidFill>
-          <a:ln w="9525">
-            <a:solidFill>
-              <a:srgbClr val="D3DCE8"/>
-            </a:solidFill>
+          <a:ln>
+            <a:noFill/>
           </a:ln>
           <a:effectLst/>
         </p:spPr>
@@ -6916,23 +7315,32 @@
           </a:fontRef>
         </p:style>
         <p:txBody>
-          <a:bodyPr rtlCol="0" anchor="ctr"/>
+          <a:bodyPr rtlCol="0" anchor="ctr" wrap="square" lIns="0" tIns="0" rIns="0" bIns="0"/>
           <a:lstStyle/>
           <a:p>
             <a:pPr algn="ctr"/>
-          </a:p>
-        </p:txBody>
-      </p:sp>
-      <p:sp>
-        <p:nvSpPr>
-          <p:cNvPr id="11" name="TextBox 10"/>
+            <a:r>
+              <a:rPr sz="1000" b="1" i="0">
+                <a:solidFill>
+                  <a:srgbClr val="FFFFFF"/>
+                </a:solidFill>
+                <a:latin typeface="Calibri"/>
+              </a:rPr>
+              <a:t>IN THE PAPER</a:t>
+            </a:r>
+          </a:p>
+        </p:txBody>
+      </p:sp>
+      <p:sp>
+        <p:nvSpPr>
+          <p:cNvPr id="6" name="TextBox 5"/>
           <p:cNvSpPr txBox="1"/>
           <p:nvPr/>
         </p:nvSpPr>
         <p:spPr>
           <a:xfrm>
-            <a:off x="8046720" y="2816352"/>
-            <a:ext cx="3474720" cy="502920"/>
+            <a:off x="2194560" y="1508760"/>
+            <a:ext cx="4937760" cy="329184"/>
           </a:xfrm>
           <a:prstGeom prst="rect">
             <a:avLst/>
@@ -6947,27 +7355,45 @@
           <a:p>
             <a:pPr algn="l"/>
             <a:r>
-              <a:rPr sz="2600" b="1" i="0">
-                <a:solidFill>
-                  <a:srgbClr val="0B5CAD"/>
-                </a:solidFill>
-                <a:latin typeface="Cambria"/>
-              </a:rPr>
-              <a:t>1.00 vs 0.85</a:t>
-            </a:r>
-          </a:p>
-        </p:txBody>
-      </p:sp>
-      <p:sp>
-        <p:nvSpPr>
-          <p:cNvPr id="12" name="TextBox 11"/>
+              <a:rPr sz="1400" b="1" i="0">
+                <a:solidFill>
+                  <a:srgbClr val="13233A"/>
+                </a:solidFill>
+                <a:latin typeface="Calibri"/>
+              </a:rPr>
+              <a:t>Practice (training) vs exam (test) accuracy [1]</a:t>
+            </a:r>
+          </a:p>
+        </p:txBody>
+      </p:sp>
+      <p:graphicFrame>
+        <p:nvGraphicFramePr>
+          <p:cNvPr id="7" name="chart" descr="Training vs test accuracy for 7 models; every model loses 6 to 16 points on the test"/>
+          <p:cNvGraphicFramePr>
+            <a:graphicFrameLocks noGrp="1"/>
+          </p:cNvGraphicFramePr>
+          <p:nvPr/>
+        </p:nvGraphicFramePr>
+        <p:xfrm>
+          <a:off x="685800" y="1847088"/>
+          <a:ext cx="6446520" cy="2240280"/>
+        </p:xfrm>
+        <a:graphic>
+          <a:graphicData uri="http://schemas.openxmlformats.org/drawingml/2006/chart">
+            <c:chart xmlns:c="http://schemas.openxmlformats.org/drawingml/2006/chart" r:id="rId2"/>
+          </a:graphicData>
+        </a:graphic>
+      </p:graphicFrame>
+      <p:sp>
+        <p:nvSpPr>
+          <p:cNvPr id="8" name="TextBox 7"/>
           <p:cNvSpPr txBox="1"/>
           <p:nvPr/>
         </p:nvSpPr>
         <p:spPr>
           <a:xfrm>
-            <a:off x="8046720" y="3337560"/>
-            <a:ext cx="3429000" cy="640080"/>
+            <a:off x="777240" y="4087368"/>
+            <a:ext cx="6400800" cy="228600"/>
           </a:xfrm>
           <a:prstGeom prst="rect">
             <a:avLst/>
@@ -6982,40 +7408,38 @@
           <a:p>
             <a:pPr algn="l"/>
             <a:r>
-              <a:rPr sz="1250" b="0" i="0">
-                <a:solidFill>
-                  <a:srgbClr val="13233A"/>
-                </a:solidFill>
-                <a:latin typeface="Calibri"/>
-              </a:rPr>
-              <a:t>LightGBM's test score is reported two ways in the same paper</a:t>
-            </a:r>
-          </a:p>
-        </p:txBody>
-      </p:sp>
-      <p:sp>
-        <p:nvSpPr>
-          <p:cNvPr id="13" name="loss-card-3"/>
+              <a:rPr sz="1100" b="0" i="0">
+                <a:solidFill>
+                  <a:srgbClr val="5A6B80"/>
+                </a:solidFill>
+                <a:latin typeface="Calibri"/>
+              </a:rPr>
+              <a:t>*LightGBM: the abstract says 1.00 → 0.85. Tables 5, 6 and 8 print it reversed.</a:t>
+            </a:r>
+          </a:p>
+        </p:txBody>
+      </p:sp>
+      <p:sp>
+        <p:nvSpPr>
+          <p:cNvPr id="9" name="Rounded Rectangle 8"/>
           <p:cNvSpPr/>
           <p:nvPr/>
         </p:nvSpPr>
         <p:spPr>
           <a:xfrm>
-            <a:off x="7818120" y="4114800"/>
-            <a:ext cx="3822191" cy="1261872"/>
+            <a:off x="777240" y="4389120"/>
+            <a:ext cx="2057400" cy="822960"/>
           </a:xfrm>
           <a:prstGeom prst="roundRect">
             <a:avLst>
-              <a:gd name="adj" fmla="val 8000"/>
+              <a:gd name="adj" fmla="val 10000"/>
             </a:avLst>
           </a:prstGeom>
           <a:solidFill>
-            <a:srgbClr val="FFFFFF"/>
+            <a:srgbClr val="E6EEF8"/>
           </a:solidFill>
-          <a:ln w="9525">
-            <a:solidFill>
-              <a:srgbClr val="D3DCE8"/>
-            </a:solidFill>
+          <a:ln>
+            <a:noFill/>
           </a:ln>
           <a:effectLst/>
         </p:spPr>
@@ -7043,14 +7467,14 @@
       </p:sp>
       <p:sp>
         <p:nvSpPr>
-          <p:cNvPr id="14" name="TextBox 13"/>
+          <p:cNvPr id="10" name="TextBox 9"/>
           <p:cNvSpPr txBox="1"/>
           <p:nvPr/>
         </p:nvSpPr>
         <p:spPr>
           <a:xfrm>
-            <a:off x="8046720" y="4187952"/>
-            <a:ext cx="3474720" cy="502920"/>
+            <a:off x="886968" y="4416552"/>
+            <a:ext cx="1874519" cy="347472"/>
           </a:xfrm>
           <a:prstGeom prst="rect">
             <a:avLst/>
@@ -7065,27 +7489,27 @@
           <a:p>
             <a:pPr algn="l"/>
             <a:r>
-              <a:rPr sz="2600" b="1" i="0">
+              <a:rPr sz="1800" b="1" i="0">
                 <a:solidFill>
                   <a:srgbClr val="0B5CAD"/>
                 </a:solidFill>
                 <a:latin typeface="Cambria"/>
               </a:rPr>
-              <a:t>15%  ·  12%</a:t>
-            </a:r>
-          </a:p>
-        </p:txBody>
-      </p:sp>
-      <p:sp>
-        <p:nvSpPr>
-          <p:cNvPr id="15" name="TextBox 14"/>
+              <a:t>6–16 pts</a:t>
+            </a:r>
+          </a:p>
+        </p:txBody>
+      </p:sp>
+      <p:sp>
+        <p:nvSpPr>
+          <p:cNvPr id="11" name="TextBox 10"/>
           <p:cNvSpPr txBox="1"/>
           <p:nvPr/>
         </p:nvSpPr>
         <p:spPr>
           <a:xfrm>
-            <a:off x="8046720" y="4709160"/>
-            <a:ext cx="3429000" cy="640080"/>
+            <a:off x="886968" y="4754880"/>
+            <a:ext cx="1874519" cy="438912"/>
           </a:xfrm>
           <a:prstGeom prst="rect">
             <a:avLst/>
@@ -7100,31 +7524,263 @@
           <a:p>
             <a:pPr algn="l"/>
             <a:r>
-              <a:rPr sz="1250" b="0" i="0">
+              <a:rPr sz="1050" b="0" i="0">
                 <a:solidFill>
                   <a:srgbClr val="13233A"/>
                 </a:solidFill>
                 <a:latin typeface="Calibri"/>
               </a:rPr>
-              <a:t>of attacks missed, and of normal traffic falsely flagged, in LightGBM's own matrix (our calculation)</a:t>
-            </a:r>
-          </a:p>
-        </p:txBody>
-      </p:sp>
-      <p:sp>
-        <p:nvSpPr>
-          <p:cNvPr id="16" name="Rounded Rectangle 15"/>
+              <a:t>lost from practice to exam, in every model</a:t>
+            </a:r>
+          </a:p>
+        </p:txBody>
+      </p:sp>
+      <p:sp>
+        <p:nvSpPr>
+          <p:cNvPr id="12" name="Rounded Rectangle 11"/>
           <p:cNvSpPr/>
           <p:nvPr/>
         </p:nvSpPr>
         <p:spPr>
           <a:xfrm>
-            <a:off x="548640" y="5486400"/>
-            <a:ext cx="11091672" cy="713232"/>
+            <a:off x="2926080" y="4389120"/>
+            <a:ext cx="2057400" cy="822960"/>
           </a:xfrm>
           <a:prstGeom prst="roundRect">
             <a:avLst>
-              <a:gd name="adj" fmla="val 8000"/>
+              <a:gd name="adj" fmla="val 10000"/>
+            </a:avLst>
+          </a:prstGeom>
+          <a:solidFill>
+            <a:srgbClr val="E6EEF8"/>
+          </a:solidFill>
+          <a:ln>
+            <a:noFill/>
+          </a:ln>
+          <a:effectLst/>
+        </p:spPr>
+        <p:style>
+          <a:lnRef idx="1">
+            <a:schemeClr val="accent1"/>
+          </a:lnRef>
+          <a:fillRef idx="3">
+            <a:schemeClr val="accent1"/>
+          </a:fillRef>
+          <a:effectRef idx="2">
+            <a:schemeClr val="accent1"/>
+          </a:effectRef>
+          <a:fontRef idx="minor">
+            <a:schemeClr val="lt1"/>
+          </a:fontRef>
+        </p:style>
+        <p:txBody>
+          <a:bodyPr rtlCol="0" anchor="ctr"/>
+          <a:lstStyle/>
+          <a:p>
+            <a:pPr algn="ctr"/>
+          </a:p>
+        </p:txBody>
+      </p:sp>
+      <p:sp>
+        <p:nvSpPr>
+          <p:cNvPr id="13" name="TextBox 12"/>
+          <p:cNvSpPr txBox="1"/>
+          <p:nvPr/>
+        </p:nvSpPr>
+        <p:spPr>
+          <a:xfrm>
+            <a:off x="3035808" y="4416552"/>
+            <a:ext cx="1874519" cy="347472"/>
+          </a:xfrm>
+          <a:prstGeom prst="rect">
+            <a:avLst/>
+          </a:prstGeom>
+          <a:noFill/>
+        </p:spPr>
+        <p:txBody>
+          <a:bodyPr wrap="square" lIns="0" tIns="0" rIns="0" bIns="0" anchor="ctr">
+            <a:spAutoFit/>
+          </a:bodyPr>
+          <a:lstStyle/>
+          <a:p>
+            <a:pPr algn="l"/>
+            <a:r>
+              <a:rPr sz="1800" b="1" i="0">
+                <a:solidFill>
+                  <a:srgbClr val="0B5CAD"/>
+                </a:solidFill>
+                <a:latin typeface="Cambria"/>
+              </a:rPr>
+              <a:t>1.00 vs 0.85</a:t>
+            </a:r>
+          </a:p>
+        </p:txBody>
+      </p:sp>
+      <p:sp>
+        <p:nvSpPr>
+          <p:cNvPr id="14" name="TextBox 13"/>
+          <p:cNvSpPr txBox="1"/>
+          <p:nvPr/>
+        </p:nvSpPr>
+        <p:spPr>
+          <a:xfrm>
+            <a:off x="3035808" y="4754880"/>
+            <a:ext cx="1874519" cy="438912"/>
+          </a:xfrm>
+          <a:prstGeom prst="rect">
+            <a:avLst/>
+          </a:prstGeom>
+          <a:noFill/>
+        </p:spPr>
+        <p:txBody>
+          <a:bodyPr wrap="square" lIns="0" tIns="0" rIns="0" bIns="0" anchor="t">
+            <a:spAutoFit/>
+          </a:bodyPr>
+          <a:lstStyle/>
+          <a:p>
+            <a:pPr algn="l"/>
+            <a:r>
+              <a:rPr sz="1050" b="0" i="0">
+                <a:solidFill>
+                  <a:srgbClr val="13233A"/>
+                </a:solidFill>
+                <a:latin typeface="Calibri"/>
+              </a:rPr>
+              <a:t>LightGBM's test score, reported two ways</a:t>
+            </a:r>
+          </a:p>
+        </p:txBody>
+      </p:sp>
+      <p:sp>
+        <p:nvSpPr>
+          <p:cNvPr id="15" name="Rounded Rectangle 14"/>
+          <p:cNvSpPr/>
+          <p:nvPr/>
+        </p:nvSpPr>
+        <p:spPr>
+          <a:xfrm>
+            <a:off x="5074920" y="4389120"/>
+            <a:ext cx="2057400" cy="822960"/>
+          </a:xfrm>
+          <a:prstGeom prst="roundRect">
+            <a:avLst>
+              <a:gd name="adj" fmla="val 10000"/>
+            </a:avLst>
+          </a:prstGeom>
+          <a:solidFill>
+            <a:srgbClr val="E6EEF8"/>
+          </a:solidFill>
+          <a:ln>
+            <a:noFill/>
+          </a:ln>
+          <a:effectLst/>
+        </p:spPr>
+        <p:style>
+          <a:lnRef idx="1">
+            <a:schemeClr val="accent1"/>
+          </a:lnRef>
+          <a:fillRef idx="3">
+            <a:schemeClr val="accent1"/>
+          </a:fillRef>
+          <a:effectRef idx="2">
+            <a:schemeClr val="accent1"/>
+          </a:effectRef>
+          <a:fontRef idx="minor">
+            <a:schemeClr val="lt1"/>
+          </a:fontRef>
+        </p:style>
+        <p:txBody>
+          <a:bodyPr rtlCol="0" anchor="ctr"/>
+          <a:lstStyle/>
+          <a:p>
+            <a:pPr algn="ctr"/>
+          </a:p>
+        </p:txBody>
+      </p:sp>
+      <p:sp>
+        <p:nvSpPr>
+          <p:cNvPr id="16" name="TextBox 15"/>
+          <p:cNvSpPr txBox="1"/>
+          <p:nvPr/>
+        </p:nvSpPr>
+        <p:spPr>
+          <a:xfrm>
+            <a:off x="5184648" y="4416552"/>
+            <a:ext cx="1874519" cy="347472"/>
+          </a:xfrm>
+          <a:prstGeom prst="rect">
+            <a:avLst/>
+          </a:prstGeom>
+          <a:noFill/>
+        </p:spPr>
+        <p:txBody>
+          <a:bodyPr wrap="square" lIns="0" tIns="0" rIns="0" bIns="0" anchor="ctr">
+            <a:spAutoFit/>
+          </a:bodyPr>
+          <a:lstStyle/>
+          <a:p>
+            <a:pPr algn="l"/>
+            <a:r>
+              <a:rPr sz="1800" b="1" i="0">
+                <a:solidFill>
+                  <a:srgbClr val="0B5CAD"/>
+                </a:solidFill>
+                <a:latin typeface="Cambria"/>
+              </a:rPr>
+              <a:t>15%  ·  12%</a:t>
+            </a:r>
+          </a:p>
+        </p:txBody>
+      </p:sp>
+      <p:sp>
+        <p:nvSpPr>
+          <p:cNvPr id="17" name="TextBox 16"/>
+          <p:cNvSpPr txBox="1"/>
+          <p:nvPr/>
+        </p:nvSpPr>
+        <p:spPr>
+          <a:xfrm>
+            <a:off x="5184648" y="4754880"/>
+            <a:ext cx="1874519" cy="438912"/>
+          </a:xfrm>
+          <a:prstGeom prst="rect">
+            <a:avLst/>
+          </a:prstGeom>
+          <a:noFill/>
+        </p:spPr>
+        <p:txBody>
+          <a:bodyPr wrap="square" lIns="0" tIns="0" rIns="0" bIns="0" anchor="t">
+            <a:spAutoFit/>
+          </a:bodyPr>
+          <a:lstStyle/>
+          <a:p>
+            <a:pPr algn="l"/>
+            <a:r>
+              <a:rPr sz="1050" b="0" i="0">
+                <a:solidFill>
+                  <a:srgbClr val="13233A"/>
+                </a:solidFill>
+                <a:latin typeface="Calibri"/>
+              </a:rPr>
+              <a:t>attacks missed · false alarms, LightGBM (our calculation)</a:t>
+            </a:r>
+          </a:p>
+        </p:txBody>
+      </p:sp>
+      <p:sp>
+        <p:nvSpPr>
+          <p:cNvPr id="18" name="panel-industry"/>
+          <p:cNvSpPr/>
+          <p:nvPr/>
+        </p:nvSpPr>
+        <p:spPr>
+          <a:xfrm>
+            <a:off x="7452360" y="1371600"/>
+            <a:ext cx="4187952" cy="3977639"/>
+          </a:xfrm>
+          <a:prstGeom prst="roundRect">
+            <a:avLst>
+              <a:gd name="adj" fmla="val 4000"/>
             </a:avLst>
           </a:prstGeom>
           <a:solidFill>
@@ -7150,41 +7806,113 @@
           </a:fontRef>
         </p:style>
         <p:txBody>
-          <a:bodyPr rtlCol="0" anchor="ctr" wrap="square" lIns="274320" tIns="0" rIns="228600" bIns="0"/>
+          <a:bodyPr rtlCol="0" anchor="ctr"/>
+          <a:lstStyle/>
+          <a:p>
+            <a:pPr algn="ctr"/>
+          </a:p>
+        </p:txBody>
+      </p:sp>
+      <p:sp>
+        <p:nvSpPr>
+          <p:cNvPr id="19" name="Rounded Rectangle 18"/>
+          <p:cNvSpPr/>
+          <p:nvPr/>
+        </p:nvSpPr>
+        <p:spPr>
+          <a:xfrm>
+            <a:off x="7680960" y="1536192"/>
+            <a:ext cx="1371600" cy="274320"/>
+          </a:xfrm>
+          <a:prstGeom prst="roundRect">
+            <a:avLst>
+              <a:gd name="adj" fmla="val 50000"/>
+            </a:avLst>
+          </a:prstGeom>
+          <a:solidFill>
+            <a:srgbClr val="F2A900"/>
+          </a:solidFill>
+          <a:ln>
+            <a:noFill/>
+          </a:ln>
+          <a:effectLst/>
+        </p:spPr>
+        <p:style>
+          <a:lnRef idx="1">
+            <a:schemeClr val="accent1"/>
+          </a:lnRef>
+          <a:fillRef idx="3">
+            <a:schemeClr val="accent1"/>
+          </a:fillRef>
+          <a:effectRef idx="2">
+            <a:schemeClr val="accent1"/>
+          </a:effectRef>
+          <a:fontRef idx="minor">
+            <a:schemeClr val="lt1"/>
+          </a:fontRef>
+        </p:style>
+        <p:txBody>
+          <a:bodyPr rtlCol="0" anchor="ctr" wrap="square" lIns="0" tIns="0" rIns="0" bIns="0"/>
+          <a:lstStyle/>
+          <a:p>
+            <a:pPr algn="ctr"/>
+            <a:r>
+              <a:rPr sz="1000" b="1" i="0">
+                <a:solidFill>
+                  <a:srgbClr val="0B1F3A"/>
+                </a:solidFill>
+                <a:latin typeface="Calibri"/>
+              </a:rPr>
+              <a:t>IN INDUSTRY</a:t>
+            </a:r>
+          </a:p>
+        </p:txBody>
+      </p:sp>
+      <p:sp>
+        <p:nvSpPr>
+          <p:cNvPr id="20" name="TextBox 19"/>
+          <p:cNvSpPr txBox="1"/>
+          <p:nvPr/>
+        </p:nvSpPr>
+        <p:spPr>
+          <a:xfrm>
+            <a:off x="7680960" y="1901952"/>
+            <a:ext cx="3749039" cy="292608"/>
+          </a:xfrm>
+          <a:prstGeom prst="rect">
+            <a:avLst/>
+          </a:prstGeom>
+          <a:noFill/>
+        </p:spPr>
+        <p:txBody>
+          <a:bodyPr wrap="square" lIns="0" tIns="0" rIns="0" bIns="0" anchor="t">
+            <a:spAutoFit/>
+          </a:bodyPr>
           <a:lstStyle/>
           <a:p>
             <a:pPr algn="l"/>
             <a:r>
-              <a:rPr sz="1700" b="1" i="0">
-                <a:solidFill>
-                  <a:srgbClr val="F2A900"/>
-                </a:solidFill>
-                <a:latin typeface="Calibri"/>
-              </a:rPr>
-              <a:t>Like this   </a:t>
-            </a:r>
-            <a:r>
-              <a:rPr sz="1700" b="0" i="0">
+              <a:rPr sz="1400" b="1" i="0">
                 <a:solidFill>
                   <a:srgbClr val="FFFFFF"/>
                 </a:solidFill>
                 <a:latin typeface="Calibri"/>
               </a:rPr>
-              <a:t>Scoring 100% on practice questions but 85% on the exam. How much more is lost on a new exam?</a:t>
-            </a:r>
-          </a:p>
-        </p:txBody>
-      </p:sp>
-      <p:sp>
-        <p:nvSpPr>
-          <p:cNvPr id="17" name="footer"/>
+              <a:t>What failed defence costs</a:t>
+            </a:r>
+          </a:p>
+        </p:txBody>
+      </p:sp>
+      <p:sp>
+        <p:nvSpPr>
+          <p:cNvPr id="21" name="TextBox 20"/>
           <p:cNvSpPr txBox="1"/>
           <p:nvPr/>
         </p:nvSpPr>
         <p:spPr>
           <a:xfrm>
-            <a:off x="548640" y="6428232"/>
-            <a:ext cx="7132320" cy="228600"/>
+            <a:off x="7680960" y="2286000"/>
+            <a:ext cx="2377440" cy="457200"/>
           </a:xfrm>
           <a:prstGeom prst="rect">
             <a:avLst/>
@@ -7199,6 +7927,501 @@
           <a:p>
             <a:pPr algn="l"/>
             <a:r>
+              <a:rPr sz="2600" b="1" i="0">
+                <a:solidFill>
+                  <a:srgbClr val="F2A900"/>
+                </a:solidFill>
+                <a:latin typeface="Cambria"/>
+              </a:rPr>
+              <a:t>$4.99M</a:t>
+            </a:r>
+          </a:p>
+        </p:txBody>
+      </p:sp>
+      <p:sp>
+        <p:nvSpPr>
+          <p:cNvPr id="22" name="ref-2">
+            <a:hlinkClick r:id="rId3"/>
+          </p:cNvPr>
+          <p:cNvSpPr/>
+          <p:nvPr/>
+        </p:nvSpPr>
+        <p:spPr>
+          <a:xfrm>
+            <a:off x="11109960" y="2377440"/>
+            <a:ext cx="402336" cy="256032"/>
+          </a:xfrm>
+          <a:prstGeom prst="roundRect">
+            <a:avLst>
+              <a:gd name="adj" fmla="val 50000"/>
+            </a:avLst>
+          </a:prstGeom>
+          <a:solidFill>
+            <a:srgbClr val="FFFFFF"/>
+          </a:solidFill>
+          <a:ln w="9525">
+            <a:solidFill>
+              <a:srgbClr val="0B5CAD"/>
+            </a:solidFill>
+          </a:ln>
+          <a:effectLst/>
+        </p:spPr>
+        <p:style>
+          <a:lnRef idx="1">
+            <a:schemeClr val="accent1"/>
+          </a:lnRef>
+          <a:fillRef idx="3">
+            <a:schemeClr val="accent1"/>
+          </a:fillRef>
+          <a:effectRef idx="2">
+            <a:schemeClr val="accent1"/>
+          </a:effectRef>
+          <a:fontRef idx="minor">
+            <a:schemeClr val="lt1"/>
+          </a:fontRef>
+        </p:style>
+        <p:txBody>
+          <a:bodyPr rtlCol="0" anchor="ctr" wrap="square" lIns="0" tIns="0" rIns="0" bIns="0"/>
+          <a:lstStyle/>
+          <a:p>
+            <a:pPr algn="ctr"/>
+            <a:r>
+              <a:rPr sz="1100" b="1" i="0">
+                <a:solidFill>
+                  <a:srgbClr val="0B5CAD"/>
+                </a:solidFill>
+                <a:latin typeface="Calibri"/>
+              </a:rPr>
+              <a:t>[2]</a:t>
+            </a:r>
+          </a:p>
+        </p:txBody>
+      </p:sp>
+      <p:sp>
+        <p:nvSpPr>
+          <p:cNvPr id="23" name="TextBox 22"/>
+          <p:cNvSpPr txBox="1"/>
+          <p:nvPr/>
+        </p:nvSpPr>
+        <p:spPr>
+          <a:xfrm>
+            <a:off x="7680960" y="2743200"/>
+            <a:ext cx="3749039" cy="457200"/>
+          </a:xfrm>
+          <a:prstGeom prst="rect">
+            <a:avLst/>
+          </a:prstGeom>
+          <a:noFill/>
+        </p:spPr>
+        <p:txBody>
+          <a:bodyPr wrap="square" lIns="0" tIns="0" rIns="0" bIns="0" anchor="t">
+            <a:spAutoFit/>
+          </a:bodyPr>
+          <a:lstStyle/>
+          <a:p>
+            <a:pPr algn="l"/>
+            <a:r>
+              <a:rPr sz="1250" b="0" i="0">
+                <a:solidFill>
+                  <a:srgbClr val="FFFFFF"/>
+                </a:solidFill>
+                <a:latin typeface="Calibri"/>
+              </a:rPr>
+              <a:t>average cost of one data breach worldwide, a record (+12%)</a:t>
+            </a:r>
+          </a:p>
+        </p:txBody>
+      </p:sp>
+      <p:sp>
+        <p:nvSpPr>
+          <p:cNvPr id="24" name="TextBox 23"/>
+          <p:cNvSpPr txBox="1"/>
+          <p:nvPr/>
+        </p:nvSpPr>
+        <p:spPr>
+          <a:xfrm>
+            <a:off x="7680960" y="3273552"/>
+            <a:ext cx="2377440" cy="457200"/>
+          </a:xfrm>
+          <a:prstGeom prst="rect">
+            <a:avLst/>
+          </a:prstGeom>
+          <a:noFill/>
+        </p:spPr>
+        <p:txBody>
+          <a:bodyPr wrap="square" lIns="0" tIns="0" rIns="0" bIns="0" anchor="ctr">
+            <a:spAutoFit/>
+          </a:bodyPr>
+          <a:lstStyle/>
+          <a:p>
+            <a:pPr algn="l"/>
+            <a:r>
+              <a:rPr sz="2600" b="1" i="0">
+                <a:solidFill>
+                  <a:srgbClr val="F2A900"/>
+                </a:solidFill>
+                <a:latin typeface="Cambria"/>
+              </a:rPr>
+              <a:t>247 days</a:t>
+            </a:r>
+          </a:p>
+        </p:txBody>
+      </p:sp>
+      <p:sp>
+        <p:nvSpPr>
+          <p:cNvPr id="25" name="ref-2">
+            <a:hlinkClick r:id="rId3"/>
+          </p:cNvPr>
+          <p:cNvSpPr/>
+          <p:nvPr/>
+        </p:nvSpPr>
+        <p:spPr>
+          <a:xfrm>
+            <a:off x="11109960" y="3364992"/>
+            <a:ext cx="402336" cy="256032"/>
+          </a:xfrm>
+          <a:prstGeom prst="roundRect">
+            <a:avLst>
+              <a:gd name="adj" fmla="val 50000"/>
+            </a:avLst>
+          </a:prstGeom>
+          <a:solidFill>
+            <a:srgbClr val="FFFFFF"/>
+          </a:solidFill>
+          <a:ln w="9525">
+            <a:solidFill>
+              <a:srgbClr val="0B5CAD"/>
+            </a:solidFill>
+          </a:ln>
+          <a:effectLst/>
+        </p:spPr>
+        <p:style>
+          <a:lnRef idx="1">
+            <a:schemeClr val="accent1"/>
+          </a:lnRef>
+          <a:fillRef idx="3">
+            <a:schemeClr val="accent1"/>
+          </a:fillRef>
+          <a:effectRef idx="2">
+            <a:schemeClr val="accent1"/>
+          </a:effectRef>
+          <a:fontRef idx="minor">
+            <a:schemeClr val="lt1"/>
+          </a:fontRef>
+        </p:style>
+        <p:txBody>
+          <a:bodyPr rtlCol="0" anchor="ctr" wrap="square" lIns="0" tIns="0" rIns="0" bIns="0"/>
+          <a:lstStyle/>
+          <a:p>
+            <a:pPr algn="ctr"/>
+            <a:r>
+              <a:rPr sz="1100" b="1" i="0">
+                <a:solidFill>
+                  <a:srgbClr val="0B5CAD"/>
+                </a:solidFill>
+                <a:latin typeface="Calibri"/>
+              </a:rPr>
+              <a:t>[2]</a:t>
+            </a:r>
+          </a:p>
+        </p:txBody>
+      </p:sp>
+      <p:sp>
+        <p:nvSpPr>
+          <p:cNvPr id="26" name="TextBox 25"/>
+          <p:cNvSpPr txBox="1"/>
+          <p:nvPr/>
+        </p:nvSpPr>
+        <p:spPr>
+          <a:xfrm>
+            <a:off x="7680960" y="3730752"/>
+            <a:ext cx="3749039" cy="457200"/>
+          </a:xfrm>
+          <a:prstGeom prst="rect">
+            <a:avLst/>
+          </a:prstGeom>
+          <a:noFill/>
+        </p:spPr>
+        <p:txBody>
+          <a:bodyPr wrap="square" lIns="0" tIns="0" rIns="0" bIns="0" anchor="t">
+            <a:spAutoFit/>
+          </a:bodyPr>
+          <a:lstStyle/>
+          <a:p>
+            <a:pPr algn="l"/>
+            <a:r>
+              <a:rPr sz="1250" b="0" i="0">
+                <a:solidFill>
+                  <a:srgbClr val="FFFFFF"/>
+                </a:solidFill>
+                <a:latin typeface="Calibri"/>
+              </a:rPr>
+              <a:t>average time to find and contain a breach</a:t>
+            </a:r>
+          </a:p>
+        </p:txBody>
+      </p:sp>
+      <p:sp>
+        <p:nvSpPr>
+          <p:cNvPr id="27" name="TextBox 26"/>
+          <p:cNvSpPr txBox="1"/>
+          <p:nvPr/>
+        </p:nvSpPr>
+        <p:spPr>
+          <a:xfrm>
+            <a:off x="7680960" y="4261104"/>
+            <a:ext cx="2377440" cy="457200"/>
+          </a:xfrm>
+          <a:prstGeom prst="rect">
+            <a:avLst/>
+          </a:prstGeom>
+          <a:noFill/>
+        </p:spPr>
+        <p:txBody>
+          <a:bodyPr wrap="square" lIns="0" tIns="0" rIns="0" bIns="0" anchor="ctr">
+            <a:spAutoFit/>
+          </a:bodyPr>
+          <a:lstStyle/>
+          <a:p>
+            <a:pPr algn="l"/>
+            <a:r>
+              <a:rPr sz="2600" b="1" i="0">
+                <a:solidFill>
+                  <a:srgbClr val="F2A900"/>
+                </a:solidFill>
+                <a:latin typeface="Cambria"/>
+              </a:rPr>
+              <a:t>$20.9B</a:t>
+            </a:r>
+          </a:p>
+        </p:txBody>
+      </p:sp>
+      <p:sp>
+        <p:nvSpPr>
+          <p:cNvPr id="28" name="ref-3">
+            <a:hlinkClick r:id="rId4"/>
+          </p:cNvPr>
+          <p:cNvSpPr/>
+          <p:nvPr/>
+        </p:nvSpPr>
+        <p:spPr>
+          <a:xfrm>
+            <a:off x="11109960" y="4352544"/>
+            <a:ext cx="402336" cy="256032"/>
+          </a:xfrm>
+          <a:prstGeom prst="roundRect">
+            <a:avLst>
+              <a:gd name="adj" fmla="val 50000"/>
+            </a:avLst>
+          </a:prstGeom>
+          <a:solidFill>
+            <a:srgbClr val="FFFFFF"/>
+          </a:solidFill>
+          <a:ln w="9525">
+            <a:solidFill>
+              <a:srgbClr val="0B5CAD"/>
+            </a:solidFill>
+          </a:ln>
+          <a:effectLst/>
+        </p:spPr>
+        <p:style>
+          <a:lnRef idx="1">
+            <a:schemeClr val="accent1"/>
+          </a:lnRef>
+          <a:fillRef idx="3">
+            <a:schemeClr val="accent1"/>
+          </a:fillRef>
+          <a:effectRef idx="2">
+            <a:schemeClr val="accent1"/>
+          </a:effectRef>
+          <a:fontRef idx="minor">
+            <a:schemeClr val="lt1"/>
+          </a:fontRef>
+        </p:style>
+        <p:txBody>
+          <a:bodyPr rtlCol="0" anchor="ctr" wrap="square" lIns="0" tIns="0" rIns="0" bIns="0"/>
+          <a:lstStyle/>
+          <a:p>
+            <a:pPr algn="ctr"/>
+            <a:r>
+              <a:rPr sz="1100" b="1" i="0">
+                <a:solidFill>
+                  <a:srgbClr val="0B5CAD"/>
+                </a:solidFill>
+                <a:latin typeface="Calibri"/>
+              </a:rPr>
+              <a:t>[3]</a:t>
+            </a:r>
+          </a:p>
+        </p:txBody>
+      </p:sp>
+      <p:sp>
+        <p:nvSpPr>
+          <p:cNvPr id="29" name="TextBox 28"/>
+          <p:cNvSpPr txBox="1"/>
+          <p:nvPr/>
+        </p:nvSpPr>
+        <p:spPr>
+          <a:xfrm>
+            <a:off x="7680960" y="4718304"/>
+            <a:ext cx="3749039" cy="457200"/>
+          </a:xfrm>
+          <a:prstGeom prst="rect">
+            <a:avLst/>
+          </a:prstGeom>
+          <a:noFill/>
+        </p:spPr>
+        <p:txBody>
+          <a:bodyPr wrap="square" lIns="0" tIns="0" rIns="0" bIns="0" anchor="t">
+            <a:spAutoFit/>
+          </a:bodyPr>
+          <a:lstStyle/>
+          <a:p>
+            <a:pPr algn="l"/>
+            <a:r>
+              <a:rPr sz="1250" b="0" i="0">
+                <a:solidFill>
+                  <a:srgbClr val="FFFFFF"/>
+                </a:solidFill>
+                <a:latin typeface="Calibri"/>
+              </a:rPr>
+              <a:t>cybercrime losses reported to the FBI in 2025 (+26%)</a:t>
+            </a:r>
+          </a:p>
+        </p:txBody>
+      </p:sp>
+      <p:sp>
+        <p:nvSpPr>
+          <p:cNvPr id="30" name="link-badge"/>
+          <p:cNvSpPr/>
+          <p:nvPr/>
+        </p:nvSpPr>
+        <p:spPr>
+          <a:xfrm>
+            <a:off x="7114032" y="3200400"/>
+            <a:ext cx="365760" cy="365760"/>
+          </a:xfrm>
+          <a:prstGeom prst="ellipse">
+            <a:avLst/>
+          </a:prstGeom>
+          <a:solidFill>
+            <a:srgbClr val="F2A900"/>
+          </a:solidFill>
+          <a:ln>
+            <a:noFill/>
+          </a:ln>
+          <a:effectLst/>
+        </p:spPr>
+        <p:style>
+          <a:lnRef idx="1">
+            <a:schemeClr val="accent1"/>
+          </a:lnRef>
+          <a:fillRef idx="3">
+            <a:schemeClr val="accent1"/>
+          </a:fillRef>
+          <a:effectRef idx="2">
+            <a:schemeClr val="accent1"/>
+          </a:effectRef>
+          <a:fontRef idx="minor">
+            <a:schemeClr val="lt1"/>
+          </a:fontRef>
+        </p:style>
+        <p:txBody>
+          <a:bodyPr rtlCol="0" anchor="ctr" wrap="square" lIns="0" tIns="0" rIns="0" bIns="0"/>
+          <a:lstStyle/>
+          <a:p>
+            <a:pPr algn="ctr"/>
+            <a:r>
+              <a:rPr sz="1600" b="1" i="0">
+                <a:solidFill>
+                  <a:srgbClr val="0B1F3A"/>
+                </a:solidFill>
+                <a:latin typeface="Calibri"/>
+              </a:rPr>
+              <a:t>→</a:t>
+            </a:r>
+          </a:p>
+        </p:txBody>
+      </p:sp>
+      <p:sp>
+        <p:nvSpPr>
+          <p:cNvPr id="31" name="Rounded Rectangle 30"/>
+          <p:cNvSpPr/>
+          <p:nvPr/>
+        </p:nvSpPr>
+        <p:spPr>
+          <a:xfrm>
+            <a:off x="548640" y="5486400"/>
+            <a:ext cx="11091672" cy="713232"/>
+          </a:xfrm>
+          <a:prstGeom prst="roundRect">
+            <a:avLst>
+              <a:gd name="adj" fmla="val 8000"/>
+            </a:avLst>
+          </a:prstGeom>
+          <a:solidFill>
+            <a:srgbClr val="0B5CAD"/>
+          </a:solidFill>
+          <a:ln>
+            <a:noFill/>
+          </a:ln>
+          <a:effectLst/>
+        </p:spPr>
+        <p:style>
+          <a:lnRef idx="1">
+            <a:schemeClr val="accent1"/>
+          </a:lnRef>
+          <a:fillRef idx="3">
+            <a:schemeClr val="accent1"/>
+          </a:fillRef>
+          <a:effectRef idx="2">
+            <a:schemeClr val="accent1"/>
+          </a:effectRef>
+          <a:fontRef idx="minor">
+            <a:schemeClr val="lt1"/>
+          </a:fontRef>
+        </p:style>
+        <p:txBody>
+          <a:bodyPr rtlCol="0" anchor="ctr" wrap="square" lIns="274320" tIns="0" rIns="228600" bIns="0"/>
+          <a:lstStyle/>
+          <a:p>
+            <a:pPr algn="l"/>
+            <a:r>
+              <a:rPr sz="1600" b="0" i="0">
+                <a:solidFill>
+                  <a:srgbClr val="FFFFFF"/>
+                </a:solidFill>
+                <a:latin typeface="Calibri"/>
+              </a:rPr>
+              <a:t>Every point lost on the exam is a missed attack or a false alarm in the real world, and that is where the money goes.</a:t>
+            </a:r>
+          </a:p>
+        </p:txBody>
+      </p:sp>
+      <p:sp>
+        <p:nvSpPr>
+          <p:cNvPr id="32" name="footer"/>
+          <p:cNvSpPr txBox="1"/>
+          <p:nvPr/>
+        </p:nvSpPr>
+        <p:spPr>
+          <a:xfrm>
+            <a:off x="548640" y="6428232"/>
+            <a:ext cx="7132320" cy="228600"/>
+          </a:xfrm>
+          <a:prstGeom prst="rect">
+            <a:avLst/>
+          </a:prstGeom>
+          <a:noFill/>
+        </p:spPr>
+        <p:txBody>
+          <a:bodyPr wrap="square" lIns="0" tIns="0" rIns="0" bIns="0" anchor="ctr">
+            <a:spAutoFit/>
+          </a:bodyPr>
+          <a:lstStyle/>
+          <a:p>
+            <a:pPr algn="l"/>
+            <a:r>
               <a:rPr sz="1000" b="0" i="0">
                 <a:solidFill>
                   <a:srgbClr val="5A6B80"/>
@@ -7212,8 +8435,8 @@
       </p:sp>
       <p:sp>
         <p:nvSpPr>
-          <p:cNvPr id="18" name="nav-1">
-            <a:hlinkClick action="ppaction://hlinksldjump" r:id="rId3"/>
+          <p:cNvPr id="33" name="nav-1">
+            <a:hlinkClick action="ppaction://hlinksldjump" r:id="rId5"/>
           </p:cNvPr>
           <p:cNvSpPr/>
           <p:nvPr/>
@@ -7267,8 +8490,8 @@
       </p:sp>
       <p:sp>
         <p:nvSpPr>
-          <p:cNvPr id="19" name="nav-2">
-            <a:hlinkClick action="ppaction://hlinksldjump" r:id="rId4"/>
+          <p:cNvPr id="34" name="nav-2">
+            <a:hlinkClick action="ppaction://hlinksldjump" r:id="rId6"/>
           </p:cNvPr>
           <p:cNvSpPr/>
           <p:nvPr/>
@@ -7322,8 +8545,8 @@
       </p:sp>
       <p:sp>
         <p:nvSpPr>
-          <p:cNvPr id="20" name="nav-3">
-            <a:hlinkClick action="ppaction://hlinksldjump" r:id="rId5"/>
+          <p:cNvPr id="35" name="nav-3">
+            <a:hlinkClick action="ppaction://hlinksldjump" r:id="rId7"/>
           </p:cNvPr>
           <p:cNvSpPr/>
           <p:nvPr/>
@@ -7377,8 +8600,8 @@
       </p:sp>
       <p:sp>
         <p:nvSpPr>
-          <p:cNvPr id="21" name="nav-4">
-            <a:hlinkClick action="ppaction://hlinksldjump" r:id="rId6"/>
+          <p:cNvPr id="36" name="nav-4">
+            <a:hlinkClick action="ppaction://hlinksldjump" r:id="rId8"/>
           </p:cNvPr>
           <p:cNvSpPr/>
           <p:nvPr/>
@@ -7432,8 +8655,8 @@
       </p:sp>
       <p:sp>
         <p:nvSpPr>
-          <p:cNvPr id="22" name="nav-5">
-            <a:hlinkClick action="ppaction://hlinksldjump" r:id="rId7"/>
+          <p:cNvPr id="37" name="nav-5">
+            <a:hlinkClick action="ppaction://hlinksldjump" r:id="rId9"/>
           </p:cNvPr>
           <p:cNvSpPr/>
           <p:nvPr/>
@@ -7487,8 +8710,8 @@
       </p:sp>
       <p:sp>
         <p:nvSpPr>
-          <p:cNvPr id="23" name="nav-6">
-            <a:hlinkClick action="ppaction://hlinksldjump" r:id="rId8"/>
+          <p:cNvPr id="38" name="nav-6">
+            <a:hlinkClick action="ppaction://hlinksldjump" r:id="rId10"/>
           </p:cNvPr>
           <p:cNvSpPr/>
           <p:nvPr/>
@@ -13551,6 +14774,25 @@
               </a:rPr>
               <a:t>doi.org/10.1109/ACCESS.2025.3526988</a:t>
             </a:r>
+            <a:r>
+              <a:rPr sz="1300" b="0" i="0">
+                <a:solidFill>
+                  <a:srgbClr val="13233A"/>
+                </a:solidFill>
+                <a:latin typeface="Calibri"/>
+              </a:rPr>
+              <a:t>; </a:t>
+            </a:r>
+            <a:r>
+              <a:rPr sz="1300" b="0" i="0" u="sng">
+                <a:solidFill>
+                  <a:srgbClr val="0B5CAD"/>
+                </a:solidFill>
+                <a:latin typeface="Calibri"/>
+                <a:hlinkClick r:id="rId16"/>
+              </a:rPr>
+              <a:t>IEEE Xplore 10833631</a:t>
+            </a:r>
           </a:p>
           <a:p>
             <a:pPr algn="l">
@@ -13582,7 +14824,7 @@
                   <a:srgbClr val="0B5CAD"/>
                 </a:solidFill>
                 <a:latin typeface="Calibri"/>
-                <a:hlinkClick r:id="rId16"/>
+                <a:hlinkClick r:id="rId17"/>
               </a:rPr>
               <a:t>ibm.com/think/x-force</a:t>
             </a:r>
@@ -13617,7 +14859,7 @@
                   <a:srgbClr val="0B5CAD"/>
                 </a:solidFill>
                 <a:latin typeface="Calibri"/>
-                <a:hlinkClick r:id="rId17"/>
+                <a:hlinkClick r:id="rId18"/>
               </a:rPr>
               <a:t>ic3.gov/AnnualReport</a:t>
             </a:r>
@@ -13652,7 +14894,7 @@
                   <a:srgbClr val="0B5CAD"/>
                 </a:solidFill>
                 <a:latin typeface="Calibri"/>
-                <a:hlinkClick r:id="rId18"/>
+                <a:hlinkClick r:id="rId19"/>
               </a:rPr>
               <a:t>archive.ics.uci.edu/dataset/130</a:t>
             </a:r>
@@ -13687,7 +14929,7 @@
                   <a:srgbClr val="0B5CAD"/>
                 </a:solidFill>
                 <a:latin typeface="Calibri"/>
-                <a:hlinkClick r:id="rId19"/>
+                <a:hlinkClick r:id="rId20"/>
               </a:rPr>
               <a:t>proceedings.neurips.cc</a:t>
             </a:r>
@@ -13767,7 +15009,7 @@
       <p:sp>
         <p:nvSpPr>
           <p:cNvPr id="50" name="nav-1">
-            <a:hlinkClick action="ppaction://hlinksldjump" r:id="rId20"/>
+            <a:hlinkClick action="ppaction://hlinksldjump" r:id="rId21"/>
           </p:cNvPr>
           <p:cNvSpPr/>
           <p:nvPr/>
@@ -13822,7 +15064,7 @@
       <p:sp>
         <p:nvSpPr>
           <p:cNvPr id="51" name="nav-2">
-            <a:hlinkClick action="ppaction://hlinksldjump" r:id="rId21"/>
+            <a:hlinkClick action="ppaction://hlinksldjump" r:id="rId22"/>
           </p:cNvPr>
           <p:cNvSpPr/>
           <p:nvPr/>
@@ -13877,7 +15119,7 @@
       <p:sp>
         <p:nvSpPr>
           <p:cNvPr id="52" name="nav-3">
-            <a:hlinkClick action="ppaction://hlinksldjump" r:id="rId22"/>
+            <a:hlinkClick action="ppaction://hlinksldjump" r:id="rId23"/>
           </p:cNvPr>
           <p:cNvSpPr/>
           <p:nvPr/>
@@ -13932,7 +15174,7 @@
       <p:sp>
         <p:nvSpPr>
           <p:cNvPr id="53" name="nav-4">
-            <a:hlinkClick action="ppaction://hlinksldjump" r:id="rId23"/>
+            <a:hlinkClick action="ppaction://hlinksldjump" r:id="rId24"/>
           </p:cNvPr>
           <p:cNvSpPr/>
           <p:nvPr/>
@@ -13987,7 +15229,7 @@
       <p:sp>
         <p:nvSpPr>
           <p:cNvPr id="54" name="nav-5">
-            <a:hlinkClick action="ppaction://hlinksldjump" r:id="rId24"/>
+            <a:hlinkClick action="ppaction://hlinksldjump" r:id="rId25"/>
           </p:cNvPr>
           <p:cNvSpPr/>
           <p:nvPr/>
@@ -14042,7 +15284,7 @@
       <p:sp>
         <p:nvSpPr>
           <p:cNvPr id="55" name="nav-6">
-            <a:hlinkClick action="ppaction://hlinksldjump" r:id="rId25"/>
+            <a:hlinkClick action="ppaction://hlinksldjump" r:id="rId26"/>
           </p:cNvPr>
           <p:cNvSpPr/>
           <p:nvPr/>

</xml_diff>